<commit_message>
add: 5W1H slide/section to kadai deck & page
</commit_message>
<xml_diff>
--- a/課題設定・分析_Onda.pptx
+++ b/課題設定・分析_Onda.pptx
@@ -12,6 +12,7 @@
     <p:sldId id="260" r:id="rId11"/>
     <p:sldId id="261" r:id="rId12"/>
     <p:sldId id="262" r:id="rId13"/>
+    <p:sldId id="263" r:id="rId14"/>
   </p:sldIdLst>
   <p:sldSz cx="12188952" cy="6858000" type="screen4x3"/>
   <p:notesSz cx="6858000" cy="9144000"/>
@@ -3652,7 +3653,7 @@
                 <a:ea typeface="Meiryo"/>
                 <a:cs typeface="Meiryo"/>
               </a:rPr>
-              <a:t>発表の流れ：ゴール → 現状 → 課題設定 → 課題分析①原因 → ②影響 → まとめ</a:t>
+              <a:t>発表の流れ：ゴール → 現状 → 課題設定 → 5W1H確認 → 課題分析①原因 → ②影響 → まとめ</a:t>
             </a:r>
           </a:p>
         </p:txBody>
@@ -5755,7 +5756,7 @@
                 <a:ea typeface="Meiryo"/>
                 <a:cs typeface="Meiryo"/>
               </a:rPr>
-              <a:t>(04) 課題分析① — なぜ起きるか（原因3分解）</a:t>
+              <a:t>(04) 課題設定補助 — 問題を5W1Hで精確にする</a:t>
             </a:r>
           </a:p>
         </p:txBody>
@@ -5798,7 +5799,7 @@
                 <a:ea typeface="Meiryo"/>
                 <a:cs typeface="Meiryo"/>
               </a:rPr>
-              <a:t>原因は3つ。</a:t>
+              <a:t>6問で裏取りする。</a:t>
             </a:r>
           </a:p>
         </p:txBody>
@@ -5811,8 +5812,8 @@
         </p:nvSpPr>
         <p:spPr>
           <a:xfrm>
-            <a:off x="548640" y="1508760"/>
-            <a:ext cx="3566160" cy="3017520"/>
+            <a:off x="548640" y="1463040"/>
+            <a:ext cx="5394960" cy="1170432"/>
           </a:xfrm>
           <a:prstGeom prst="roundRect">
             <a:avLst>
@@ -5858,8 +5859,8 @@
         </p:nvSpPr>
         <p:spPr>
           <a:xfrm>
-            <a:off x="777240" y="1737360"/>
-            <a:ext cx="3108960" cy="457200"/>
+            <a:off x="822959" y="1581912"/>
+            <a:ext cx="4846320" cy="411480"/>
           </a:xfrm>
           <a:prstGeom prst="rect">
             <a:avLst/>
@@ -5872,23 +5873,23 @@
           </a:bodyPr>
           <a:lstStyle/>
           <a:p>
-            <a:pPr algn="ctr">
+            <a:pPr algn="l">
               <a:lnSpc>
                 <a:spcPct val="115000"/>
               </a:lnSpc>
-              <a:defRPr sz="1300" b="1">
-                <a:solidFill>
-                  <a:srgbClr val="111311"/>
-                </a:solidFill>
-              </a:defRPr>
-            </a:pPr>
-            <a:r>
-              <a:rPr>
-                <a:latin typeface="Meiryo"/>
-                <a:ea typeface="Meiryo"/>
-                <a:cs typeface="Meiryo"/>
-              </a:rPr>
-              <a:t>原因A：手順不明</a:t>
+              <a:defRPr sz="1400" b="1">
+                <a:solidFill>
+                  <a:srgbClr val="B91C1C"/>
+                </a:solidFill>
+              </a:defRPr>
+            </a:pPr>
+            <a:r>
+              <a:rPr>
+                <a:latin typeface="Meiryo"/>
+                <a:ea typeface="Meiryo"/>
+                <a:cs typeface="Meiryo"/>
+              </a:rPr>
+              <a:t>Who 誰が</a:t>
             </a:r>
           </a:p>
         </p:txBody>
@@ -5901,8 +5902,8 @@
         </p:nvSpPr>
         <p:spPr>
           <a:xfrm>
-            <a:off x="777240" y="2377440"/>
-            <a:ext cx="3108960" cy="1463040"/>
+            <a:off x="822959" y="2029968"/>
+            <a:ext cx="4846320" cy="548640"/>
           </a:xfrm>
           <a:prstGeom prst="rect">
             <a:avLst/>
@@ -5915,89 +5916,37 @@
           </a:bodyPr>
           <a:lstStyle/>
           <a:p>
-            <a:pPr algn="ctr">
+            <a:pPr algn="l">
               <a:lnSpc>
                 <a:spcPct val="115000"/>
               </a:lnSpc>
               <a:defRPr sz="1200" b="0">
                 <a:solidFill>
-                  <a:srgbClr val="333333"/>
-                </a:solidFill>
-              </a:defRPr>
-            </a:pPr>
-            <a:r>
-              <a:rPr>
-                <a:latin typeface="Meiryo"/>
-                <a:ea typeface="Meiryo"/>
-                <a:cs typeface="Meiryo"/>
-              </a:rPr>
-              <a:t>53%は診断を試すも</a:t>
-            </a:r>
-            <a:br/>
-            <a:r>
-              <a:rPr>
-                <a:latin typeface="Meiryo"/>
-                <a:ea typeface="Meiryo"/>
-                <a:cs typeface="Meiryo"/>
-              </a:rPr>
-              <a:t>職種と結びつかない</a:t>
-            </a:r>
-          </a:p>
-        </p:txBody>
-      </p:sp>
-      <p:sp>
-        <p:nvSpPr>
-          <p:cNvPr id="7" name="TextBox 6"/>
-          <p:cNvSpPr txBox="1"/>
-          <p:nvPr/>
-        </p:nvSpPr>
-        <p:spPr>
-          <a:xfrm>
-            <a:off x="2103120" y="4617720"/>
-            <a:ext cx="457200" cy="457200"/>
-          </a:xfrm>
-          <a:prstGeom prst="rect">
-            <a:avLst/>
-          </a:prstGeom>
-          <a:noFill/>
-        </p:spPr>
-        <p:txBody>
-          <a:bodyPr wrap="square" lIns="0" rIns="0" anchor="t">
-            <a:noAutofit/>
-          </a:bodyPr>
-          <a:lstStyle/>
-          <a:p>
-            <a:pPr algn="ctr">
-              <a:lnSpc>
-                <a:spcPct val="115000"/>
-              </a:lnSpc>
-              <a:defRPr sz="1400" b="1">
-                <a:solidFill>
-                  <a:srgbClr val="B91C1C"/>
-                </a:solidFill>
-              </a:defRPr>
-            </a:pPr>
-            <a:r>
-              <a:rPr>
-                <a:latin typeface="Meiryo"/>
-                <a:ea typeface="Meiryo"/>
-                <a:cs typeface="Meiryo"/>
-              </a:rPr>
-              <a:t>▼</a:t>
-            </a:r>
-          </a:p>
-        </p:txBody>
-      </p:sp>
-      <p:sp>
-        <p:nvSpPr>
-          <p:cNvPr id="8" name="Rounded Rectangle 7"/>
+                  <a:srgbClr val="111311"/>
+                </a:solidFill>
+              </a:defRPr>
+            </a:pPr>
+            <a:r>
+              <a:rPr>
+                <a:latin typeface="Meiryo"/>
+                <a:ea typeface="Meiryo"/>
+                <a:cs typeface="Meiryo"/>
+              </a:rPr>
+              <a:t>大学3年生（就活生本人）</a:t>
+            </a:r>
+          </a:p>
+        </p:txBody>
+      </p:sp>
+      <p:sp>
+        <p:nvSpPr>
+          <p:cNvPr id="7" name="Rounded Rectangle 6"/>
           <p:cNvSpPr/>
           <p:nvPr/>
         </p:nvSpPr>
         <p:spPr>
           <a:xfrm>
-            <a:off x="4297679" y="1508760"/>
-            <a:ext cx="3566160" cy="3017520"/>
+            <a:off x="6217920" y="1463040"/>
+            <a:ext cx="5394960" cy="1170432"/>
           </a:xfrm>
           <a:prstGeom prst="roundRect">
             <a:avLst>
@@ -6037,14 +5986,14 @@
       </p:sp>
       <p:sp>
         <p:nvSpPr>
-          <p:cNvPr id="9" name="TextBox 8"/>
+          <p:cNvPr id="8" name="TextBox 7"/>
           <p:cNvSpPr txBox="1"/>
           <p:nvPr/>
         </p:nvSpPr>
         <p:spPr>
           <a:xfrm>
-            <a:off x="4526279" y="1737360"/>
-            <a:ext cx="3108960" cy="457200"/>
+            <a:off x="6492240" y="1581912"/>
+            <a:ext cx="4846320" cy="411480"/>
           </a:xfrm>
           <a:prstGeom prst="rect">
             <a:avLst/>
@@ -6057,37 +6006,37 @@
           </a:bodyPr>
           <a:lstStyle/>
           <a:p>
-            <a:pPr algn="ctr">
+            <a:pPr algn="l">
               <a:lnSpc>
                 <a:spcPct val="115000"/>
               </a:lnSpc>
-              <a:defRPr sz="1300" b="1">
-                <a:solidFill>
-                  <a:srgbClr val="111311"/>
-                </a:solidFill>
-              </a:defRPr>
-            </a:pPr>
-            <a:r>
-              <a:rPr>
-                <a:latin typeface="Meiryo"/>
-                <a:ea typeface="Meiryo"/>
-                <a:cs typeface="Meiryo"/>
-              </a:rPr>
-              <a:t>原因B：ゴール不明</a:t>
-            </a:r>
-          </a:p>
-        </p:txBody>
-      </p:sp>
-      <p:sp>
-        <p:nvSpPr>
-          <p:cNvPr id="10" name="TextBox 9"/>
+              <a:defRPr sz="1400" b="1">
+                <a:solidFill>
+                  <a:srgbClr val="B91C1C"/>
+                </a:solidFill>
+              </a:defRPr>
+            </a:pPr>
+            <a:r>
+              <a:rPr>
+                <a:latin typeface="Meiryo"/>
+                <a:ea typeface="Meiryo"/>
+                <a:cs typeface="Meiryo"/>
+              </a:rPr>
+              <a:t>What 何が</a:t>
+            </a:r>
+          </a:p>
+        </p:txBody>
+      </p:sp>
+      <p:sp>
+        <p:nvSpPr>
+          <p:cNvPr id="9" name="TextBox 8"/>
           <p:cNvSpPr txBox="1"/>
           <p:nvPr/>
         </p:nvSpPr>
         <p:spPr>
           <a:xfrm>
-            <a:off x="4526279" y="2377440"/>
-            <a:ext cx="3108960" cy="1463040"/>
+            <a:off x="6492240" y="2029968"/>
+            <a:ext cx="4846320" cy="548640"/>
           </a:xfrm>
           <a:prstGeom prst="rect">
             <a:avLst/>
@@ -6100,89 +6049,37 @@
           </a:bodyPr>
           <a:lstStyle/>
           <a:p>
-            <a:pPr algn="ctr">
+            <a:pPr algn="l">
               <a:lnSpc>
                 <a:spcPct val="115000"/>
               </a:lnSpc>
               <a:defRPr sz="1200" b="0">
                 <a:solidFill>
-                  <a:srgbClr val="333333"/>
-                </a:solidFill>
-              </a:defRPr>
-            </a:pPr>
-            <a:r>
-              <a:rPr>
-                <a:latin typeface="Meiryo"/>
-                <a:ea typeface="Meiryo"/>
-                <a:cs typeface="Meiryo"/>
-              </a:rPr>
-              <a:t>信頼できる30.5%</a:t>
-            </a:r>
-            <a:br/>
-            <a:r>
-              <a:rPr>
-                <a:latin typeface="Meiryo"/>
-                <a:ea typeface="Meiryo"/>
-                <a:cs typeface="Meiryo"/>
-              </a:rPr>
-              <a:t>保留42.0%で判断停止</a:t>
-            </a:r>
-          </a:p>
-        </p:txBody>
-      </p:sp>
-      <p:sp>
-        <p:nvSpPr>
-          <p:cNvPr id="11" name="TextBox 10"/>
-          <p:cNvSpPr txBox="1"/>
-          <p:nvPr/>
-        </p:nvSpPr>
-        <p:spPr>
-          <a:xfrm>
-            <a:off x="5852159" y="4617720"/>
-            <a:ext cx="457200" cy="457200"/>
-          </a:xfrm>
-          <a:prstGeom prst="rect">
-            <a:avLst/>
-          </a:prstGeom>
-          <a:noFill/>
-        </p:spPr>
-        <p:txBody>
-          <a:bodyPr wrap="square" lIns="0" rIns="0" anchor="t">
-            <a:noAutofit/>
-          </a:bodyPr>
-          <a:lstStyle/>
-          <a:p>
-            <a:pPr algn="ctr">
-              <a:lnSpc>
-                <a:spcPct val="115000"/>
-              </a:lnSpc>
-              <a:defRPr sz="1400" b="1">
-                <a:solidFill>
-                  <a:srgbClr val="B91C1C"/>
-                </a:solidFill>
-              </a:defRPr>
-            </a:pPr>
-            <a:r>
-              <a:rPr>
-                <a:latin typeface="Meiryo"/>
-                <a:ea typeface="Meiryo"/>
-                <a:cs typeface="Meiryo"/>
-              </a:rPr>
-              <a:t>▼</a:t>
-            </a:r>
-          </a:p>
-        </p:txBody>
-      </p:sp>
-      <p:sp>
-        <p:nvSpPr>
-          <p:cNvPr id="12" name="Rounded Rectangle 11"/>
+                  <a:srgbClr val="111311"/>
+                </a:solidFill>
+              </a:defRPr>
+            </a:pPr>
+            <a:r>
+              <a:rPr>
+                <a:latin typeface="Meiryo"/>
+                <a:ea typeface="Meiryo"/>
+                <a:cs typeface="Meiryo"/>
+              </a:rPr>
+              <a:t>自己理解が不十分なままES・面接の選考に進んでしまう</a:t>
+            </a:r>
+          </a:p>
+        </p:txBody>
+      </p:sp>
+      <p:sp>
+        <p:nvSpPr>
+          <p:cNvPr id="10" name="Rounded Rectangle 9"/>
           <p:cNvSpPr/>
           <p:nvPr/>
         </p:nvSpPr>
         <p:spPr>
           <a:xfrm>
-            <a:off x="8046719" y="1508760"/>
-            <a:ext cx="3566160" cy="3017520"/>
+            <a:off x="548640" y="2761488"/>
+            <a:ext cx="5394960" cy="1170432"/>
           </a:xfrm>
           <a:prstGeom prst="roundRect">
             <a:avLst>
@@ -6222,14 +6119,14 @@
       </p:sp>
       <p:sp>
         <p:nvSpPr>
-          <p:cNvPr id="13" name="TextBox 12"/>
+          <p:cNvPr id="11" name="TextBox 10"/>
           <p:cNvSpPr txBox="1"/>
           <p:nvPr/>
         </p:nvSpPr>
         <p:spPr>
           <a:xfrm>
-            <a:off x="8275319" y="1737360"/>
-            <a:ext cx="3108960" cy="457200"/>
+            <a:off x="822959" y="2880360"/>
+            <a:ext cx="4846320" cy="411480"/>
           </a:xfrm>
           <a:prstGeom prst="rect">
             <a:avLst/>
@@ -6242,37 +6139,37 @@
           </a:bodyPr>
           <a:lstStyle/>
           <a:p>
-            <a:pPr algn="ctr">
+            <a:pPr algn="l">
               <a:lnSpc>
                 <a:spcPct val="115000"/>
               </a:lnSpc>
-              <a:defRPr sz="1300" b="1">
-                <a:solidFill>
-                  <a:srgbClr val="111311"/>
-                </a:solidFill>
-              </a:defRPr>
-            </a:pPr>
-            <a:r>
-              <a:rPr>
-                <a:latin typeface="Meiryo"/>
-                <a:ea typeface="Meiryo"/>
-                <a:cs typeface="Meiryo"/>
-              </a:rPr>
-              <a:t>原因C：時期遅れ</a:t>
-            </a:r>
-          </a:p>
-        </p:txBody>
-      </p:sp>
-      <p:sp>
-        <p:nvSpPr>
-          <p:cNvPr id="14" name="TextBox 13"/>
+              <a:defRPr sz="1400" b="1">
+                <a:solidFill>
+                  <a:srgbClr val="B91C1C"/>
+                </a:solidFill>
+              </a:defRPr>
+            </a:pPr>
+            <a:r>
+              <a:rPr>
+                <a:latin typeface="Meiryo"/>
+                <a:ea typeface="Meiryo"/>
+                <a:cs typeface="Meiryo"/>
+              </a:rPr>
+              <a:t>When いつ</a:t>
+            </a:r>
+          </a:p>
+        </p:txBody>
+      </p:sp>
+      <p:sp>
+        <p:nvSpPr>
+          <p:cNvPr id="12" name="TextBox 11"/>
           <p:cNvSpPr txBox="1"/>
           <p:nvPr/>
         </p:nvSpPr>
         <p:spPr>
           <a:xfrm>
-            <a:off x="8275319" y="2377440"/>
-            <a:ext cx="3108960" cy="1463040"/>
+            <a:off x="822959" y="3328416"/>
+            <a:ext cx="4846320" cy="548640"/>
           </a:xfrm>
           <a:prstGeom prst="rect">
             <a:avLst/>
@@ -6285,46 +6182,84 @@
           </a:bodyPr>
           <a:lstStyle/>
           <a:p>
-            <a:pPr algn="ctr">
+            <a:pPr algn="l">
               <a:lnSpc>
                 <a:spcPct val="115000"/>
               </a:lnSpc>
               <a:defRPr sz="1200" b="0">
                 <a:solidFill>
-                  <a:srgbClr val="333333"/>
-                </a:solidFill>
-              </a:defRPr>
-            </a:pPr>
-            <a:r>
-              <a:rPr>
-                <a:latin typeface="Meiryo"/>
-                <a:ea typeface="Meiryo"/>
-                <a:cs typeface="Meiryo"/>
-              </a:rPr>
-              <a:t>開始35%のみ</a:t>
-            </a:r>
-            <a:br/>
-            <a:r>
-              <a:rPr>
-                <a:latin typeface="Meiryo"/>
-                <a:ea typeface="Meiryo"/>
-                <a:cs typeface="Meiryo"/>
-              </a:rPr>
-              <a:t>秋に35.2%が逆戻り</a:t>
-            </a:r>
-          </a:p>
-        </p:txBody>
-      </p:sp>
-      <p:sp>
-        <p:nvSpPr>
-          <p:cNvPr id="15" name="TextBox 14"/>
+                  <a:srgbClr val="111311"/>
+                </a:solidFill>
+              </a:defRPr>
+            </a:pPr>
+            <a:r>
+              <a:rPr>
+                <a:latin typeface="Meiryo"/>
+                <a:ea typeface="Meiryo"/>
+                <a:cs typeface="Meiryo"/>
+              </a:rPr>
+              <a:t>3年の秋〜選考直前（開始は4-6月が35%のみ）</a:t>
+            </a:r>
+          </a:p>
+        </p:txBody>
+      </p:sp>
+      <p:sp>
+        <p:nvSpPr>
+          <p:cNvPr id="13" name="Rounded Rectangle 12"/>
+          <p:cNvSpPr/>
+          <p:nvPr/>
+        </p:nvSpPr>
+        <p:spPr>
+          <a:xfrm>
+            <a:off x="6217920" y="2761488"/>
+            <a:ext cx="5394960" cy="1170432"/>
+          </a:xfrm>
+          <a:prstGeom prst="roundRect">
+            <a:avLst>
+              <a:gd name="adj" fmla="val 12000"/>
+            </a:avLst>
+          </a:prstGeom>
+          <a:solidFill>
+            <a:srgbClr val="FFFFFF"/>
+          </a:solidFill>
+          <a:ln w="15875">
+            <a:solidFill>
+              <a:srgbClr val="E5E1D8"/>
+            </a:solidFill>
+          </a:ln>
+        </p:spPr>
+        <p:style>
+          <a:lnRef idx="1">
+            <a:schemeClr val="accent1"/>
+          </a:lnRef>
+          <a:fillRef idx="3">
+            <a:schemeClr val="accent1"/>
+          </a:fillRef>
+          <a:effectRef idx="2">
+            <a:schemeClr val="accent1"/>
+          </a:effectRef>
+          <a:fontRef idx="minor">
+            <a:schemeClr val="lt1"/>
+          </a:fontRef>
+        </p:style>
+        <p:txBody>
+          <a:bodyPr rtlCol="0" anchor="ctr"/>
+          <a:lstStyle/>
+          <a:p>
+            <a:pPr algn="ctr"/>
+          </a:p>
+        </p:txBody>
+      </p:sp>
+      <p:sp>
+        <p:nvSpPr>
+          <p:cNvPr id="14" name="TextBox 13"/>
           <p:cNvSpPr txBox="1"/>
           <p:nvPr/>
         </p:nvSpPr>
         <p:spPr>
           <a:xfrm>
-            <a:off x="9601199" y="4617720"/>
-            <a:ext cx="457200" cy="457200"/>
+            <a:off x="6492240" y="2880360"/>
+            <a:ext cx="4846320" cy="411480"/>
           </a:xfrm>
           <a:prstGeom prst="rect">
             <a:avLst/>
@@ -6337,7 +6272,7 @@
           </a:bodyPr>
           <a:lstStyle/>
           <a:p>
-            <a:pPr algn="ctr">
+            <a:pPr algn="l">
               <a:lnSpc>
                 <a:spcPct val="115000"/>
               </a:lnSpc>
@@ -6353,7 +6288,50 @@
                 <a:ea typeface="Meiryo"/>
                 <a:cs typeface="Meiryo"/>
               </a:rPr>
-              <a:t>▼</a:t>
+              <a:t>Where どこで</a:t>
+            </a:r>
+          </a:p>
+        </p:txBody>
+      </p:sp>
+      <p:sp>
+        <p:nvSpPr>
+          <p:cNvPr id="15" name="TextBox 14"/>
+          <p:cNvSpPr txBox="1"/>
+          <p:nvPr/>
+        </p:nvSpPr>
+        <p:spPr>
+          <a:xfrm>
+            <a:off x="6492240" y="3328416"/>
+            <a:ext cx="4846320" cy="548640"/>
+          </a:xfrm>
+          <a:prstGeom prst="rect">
+            <a:avLst/>
+          </a:prstGeom>
+          <a:noFill/>
+        </p:spPr>
+        <p:txBody>
+          <a:bodyPr wrap="square" lIns="0" rIns="0" anchor="t">
+            <a:noAutofit/>
+          </a:bodyPr>
+          <a:lstStyle/>
+          <a:p>
+            <a:pPr algn="l">
+              <a:lnSpc>
+                <a:spcPct val="115000"/>
+              </a:lnSpc>
+              <a:defRPr sz="1200" b="0">
+                <a:solidFill>
+                  <a:srgbClr val="111311"/>
+                </a:solidFill>
+              </a:defRPr>
+            </a:pPr>
+            <a:r>
+              <a:rPr>
+                <a:latin typeface="Meiryo"/>
+                <a:ea typeface="Meiryo"/>
+                <a:cs typeface="Meiryo"/>
+              </a:rPr>
+              <a:t>大学・自宅。誰も教えてくれる人のいない独学の場</a:t>
             </a:r>
           </a:p>
         </p:txBody>
@@ -6366,8 +6344,274 @@
         </p:nvSpPr>
         <p:spPr>
           <a:xfrm>
-            <a:off x="548640" y="5166360"/>
-            <a:ext cx="11064240" cy="868680"/>
+            <a:off x="548640" y="4059935"/>
+            <a:ext cx="5394960" cy="1170432"/>
+          </a:xfrm>
+          <a:prstGeom prst="roundRect">
+            <a:avLst>
+              <a:gd name="adj" fmla="val 12000"/>
+            </a:avLst>
+          </a:prstGeom>
+          <a:solidFill>
+            <a:srgbClr val="FFFFFF"/>
+          </a:solidFill>
+          <a:ln w="15875">
+            <a:solidFill>
+              <a:srgbClr val="E5E1D8"/>
+            </a:solidFill>
+          </a:ln>
+        </p:spPr>
+        <p:style>
+          <a:lnRef idx="1">
+            <a:schemeClr val="accent1"/>
+          </a:lnRef>
+          <a:fillRef idx="3">
+            <a:schemeClr val="accent1"/>
+          </a:fillRef>
+          <a:effectRef idx="2">
+            <a:schemeClr val="accent1"/>
+          </a:effectRef>
+          <a:fontRef idx="minor">
+            <a:schemeClr val="lt1"/>
+          </a:fontRef>
+        </p:style>
+        <p:txBody>
+          <a:bodyPr rtlCol="0" anchor="ctr"/>
+          <a:lstStyle/>
+          <a:p>
+            <a:pPr algn="ctr"/>
+          </a:p>
+        </p:txBody>
+      </p:sp>
+      <p:sp>
+        <p:nvSpPr>
+          <p:cNvPr id="17" name="TextBox 16"/>
+          <p:cNvSpPr txBox="1"/>
+          <p:nvPr/>
+        </p:nvSpPr>
+        <p:spPr>
+          <a:xfrm>
+            <a:off x="822959" y="4178807"/>
+            <a:ext cx="4846320" cy="411480"/>
+          </a:xfrm>
+          <a:prstGeom prst="rect">
+            <a:avLst/>
+          </a:prstGeom>
+          <a:noFill/>
+        </p:spPr>
+        <p:txBody>
+          <a:bodyPr wrap="square" lIns="0" rIns="0" anchor="t">
+            <a:noAutofit/>
+          </a:bodyPr>
+          <a:lstStyle/>
+          <a:p>
+            <a:pPr algn="l">
+              <a:lnSpc>
+                <a:spcPct val="115000"/>
+              </a:lnSpc>
+              <a:defRPr sz="1400" b="1">
+                <a:solidFill>
+                  <a:srgbClr val="B91C1C"/>
+                </a:solidFill>
+              </a:defRPr>
+            </a:pPr>
+            <a:r>
+              <a:rPr>
+                <a:latin typeface="Meiryo"/>
+                <a:ea typeface="Meiryo"/>
+                <a:cs typeface="Meiryo"/>
+              </a:rPr>
+              <a:t>Why なぜ</a:t>
+            </a:r>
+          </a:p>
+        </p:txBody>
+      </p:sp>
+      <p:sp>
+        <p:nvSpPr>
+          <p:cNvPr id="18" name="TextBox 17"/>
+          <p:cNvSpPr txBox="1"/>
+          <p:nvPr/>
+        </p:nvSpPr>
+        <p:spPr>
+          <a:xfrm>
+            <a:off x="822959" y="4626864"/>
+            <a:ext cx="4846320" cy="548640"/>
+          </a:xfrm>
+          <a:prstGeom prst="rect">
+            <a:avLst/>
+          </a:prstGeom>
+          <a:noFill/>
+        </p:spPr>
+        <p:txBody>
+          <a:bodyPr wrap="square" lIns="0" rIns="0" anchor="t">
+            <a:noAutofit/>
+          </a:bodyPr>
+          <a:lstStyle/>
+          <a:p>
+            <a:pPr algn="l">
+              <a:lnSpc>
+                <a:spcPct val="115000"/>
+              </a:lnSpc>
+              <a:defRPr sz="1200" b="0">
+                <a:solidFill>
+                  <a:srgbClr val="111311"/>
+                </a:solidFill>
+              </a:defRPr>
+            </a:pPr>
+            <a:r>
+              <a:rPr>
+                <a:latin typeface="Meiryo"/>
+                <a:ea typeface="Meiryo"/>
+                <a:cs typeface="Meiryo"/>
+              </a:rPr>
+              <a:t>手順もゴールも誰にも共有されず、診断は結果で止まる</a:t>
+            </a:r>
+          </a:p>
+        </p:txBody>
+      </p:sp>
+      <p:sp>
+        <p:nvSpPr>
+          <p:cNvPr id="19" name="Rounded Rectangle 18"/>
+          <p:cNvSpPr/>
+          <p:nvPr/>
+        </p:nvSpPr>
+        <p:spPr>
+          <a:xfrm>
+            <a:off x="6217920" y="4059935"/>
+            <a:ext cx="5394960" cy="1170432"/>
+          </a:xfrm>
+          <a:prstGeom prst="roundRect">
+            <a:avLst>
+              <a:gd name="adj" fmla="val 12000"/>
+            </a:avLst>
+          </a:prstGeom>
+          <a:solidFill>
+            <a:srgbClr val="FFFFFF"/>
+          </a:solidFill>
+          <a:ln w="15875">
+            <a:solidFill>
+              <a:srgbClr val="E5E1D8"/>
+            </a:solidFill>
+          </a:ln>
+        </p:spPr>
+        <p:style>
+          <a:lnRef idx="1">
+            <a:schemeClr val="accent1"/>
+          </a:lnRef>
+          <a:fillRef idx="3">
+            <a:schemeClr val="accent1"/>
+          </a:fillRef>
+          <a:effectRef idx="2">
+            <a:schemeClr val="accent1"/>
+          </a:effectRef>
+          <a:fontRef idx="minor">
+            <a:schemeClr val="lt1"/>
+          </a:fontRef>
+        </p:style>
+        <p:txBody>
+          <a:bodyPr rtlCol="0" anchor="ctr"/>
+          <a:lstStyle/>
+          <a:p>
+            <a:pPr algn="ctr"/>
+          </a:p>
+        </p:txBody>
+      </p:sp>
+      <p:sp>
+        <p:nvSpPr>
+          <p:cNvPr id="20" name="TextBox 19"/>
+          <p:cNvSpPr txBox="1"/>
+          <p:nvPr/>
+        </p:nvSpPr>
+        <p:spPr>
+          <a:xfrm>
+            <a:off x="6492240" y="4178807"/>
+            <a:ext cx="4846320" cy="411480"/>
+          </a:xfrm>
+          <a:prstGeom prst="rect">
+            <a:avLst/>
+          </a:prstGeom>
+          <a:noFill/>
+        </p:spPr>
+        <p:txBody>
+          <a:bodyPr wrap="square" lIns="0" rIns="0" anchor="t">
+            <a:noAutofit/>
+          </a:bodyPr>
+          <a:lstStyle/>
+          <a:p>
+            <a:pPr algn="l">
+              <a:lnSpc>
+                <a:spcPct val="115000"/>
+              </a:lnSpc>
+              <a:defRPr sz="1400" b="1">
+                <a:solidFill>
+                  <a:srgbClr val="B91C1C"/>
+                </a:solidFill>
+              </a:defRPr>
+            </a:pPr>
+            <a:r>
+              <a:rPr>
+                <a:latin typeface="Meiryo"/>
+                <a:ea typeface="Meiryo"/>
+                <a:cs typeface="Meiryo"/>
+              </a:rPr>
+              <a:t>How どうやって</a:t>
+            </a:r>
+          </a:p>
+        </p:txBody>
+      </p:sp>
+      <p:sp>
+        <p:nvSpPr>
+          <p:cNvPr id="21" name="TextBox 20"/>
+          <p:cNvSpPr txBox="1"/>
+          <p:nvPr/>
+        </p:nvSpPr>
+        <p:spPr>
+          <a:xfrm>
+            <a:off x="6492240" y="4626864"/>
+            <a:ext cx="4846320" cy="548640"/>
+          </a:xfrm>
+          <a:prstGeom prst="rect">
+            <a:avLst/>
+          </a:prstGeom>
+          <a:noFill/>
+        </p:spPr>
+        <p:txBody>
+          <a:bodyPr wrap="square" lIns="0" rIns="0" anchor="t">
+            <a:noAutofit/>
+          </a:bodyPr>
+          <a:lstStyle/>
+          <a:p>
+            <a:pPr algn="l">
+              <a:lnSpc>
+                <a:spcPct val="115000"/>
+              </a:lnSpc>
+              <a:defRPr sz="1200" b="0">
+                <a:solidFill>
+                  <a:srgbClr val="111311"/>
+                </a:solidFill>
+              </a:defRPr>
+            </a:pPr>
+            <a:r>
+              <a:rPr>
+                <a:latin typeface="Meiryo"/>
+                <a:ea typeface="Meiryo"/>
+                <a:cs typeface="Meiryo"/>
+              </a:rPr>
+              <a:t>無数のツール・記事を繰り返すも深掘りできず言語化に至らない</a:t>
+            </a:r>
+          </a:p>
+        </p:txBody>
+      </p:sp>
+      <p:sp>
+        <p:nvSpPr>
+          <p:cNvPr id="22" name="Rounded Rectangle 21"/>
+          <p:cNvSpPr/>
+          <p:nvPr/>
+        </p:nvSpPr>
+        <p:spPr>
+          <a:xfrm>
+            <a:off x="548640" y="5440680"/>
+            <a:ext cx="11064240" cy="822960"/>
           </a:xfrm>
           <a:prstGeom prst="roundRect">
             <a:avLst>
@@ -6407,14 +6651,14 @@
       </p:sp>
       <p:sp>
         <p:nvSpPr>
-          <p:cNvPr id="17" name="TextBox 16"/>
+          <p:cNvPr id="23" name="TextBox 22"/>
           <p:cNvSpPr txBox="1"/>
           <p:nvPr/>
         </p:nvSpPr>
         <p:spPr>
           <a:xfrm>
-            <a:off x="822960" y="5303520"/>
-            <a:ext cx="10515600" cy="594360"/>
+            <a:off x="822960" y="5577840"/>
+            <a:ext cx="10515600" cy="548640"/>
           </a:xfrm>
           <a:prstGeom prst="rect">
             <a:avLst/>
@@ -6443,7 +6687,7 @@
                 <a:ea typeface="Meiryo"/>
                 <a:cs typeface="Meiryo"/>
               </a:rPr>
-              <a:t>→ 土台ゼロで選考 → 落ちる → 戻る の往復で時間と自信を失う</a:t>
+              <a:t>Why と How の空白が本質 ＝「やり方とゴールが分からない」と突き止まる</a:t>
             </a:r>
           </a:p>
         </p:txBody>
@@ -6512,7 +6756,7 @@
                 <a:ea typeface="Meiryo"/>
                 <a:cs typeface="Meiryo"/>
               </a:rPr>
-              <a:t>(05) 課題分析② — 放置すると誰が損するか</a:t>
+              <a:t>(05) 課題分析① — なぜ起きるか（原因3分解）</a:t>
             </a:r>
           </a:p>
         </p:txBody>
@@ -6555,7 +6799,7 @@
                 <a:ea typeface="Meiryo"/>
                 <a:cs typeface="Meiryo"/>
               </a:rPr>
-              <a:t>三者損失マトリクス。</a:t>
+              <a:t>原因は3つ。</a:t>
             </a:r>
           </a:p>
         </p:txBody>
@@ -6568,8 +6812,563 @@
         </p:nvSpPr>
         <p:spPr>
           <a:xfrm>
-            <a:off x="548640" y="1463040"/>
-            <a:ext cx="11064240" cy="548640"/>
+            <a:off x="548640" y="1508760"/>
+            <a:ext cx="3566160" cy="3017520"/>
+          </a:xfrm>
+          <a:prstGeom prst="roundRect">
+            <a:avLst>
+              <a:gd name="adj" fmla="val 12000"/>
+            </a:avLst>
+          </a:prstGeom>
+          <a:solidFill>
+            <a:srgbClr val="FFFFFF"/>
+          </a:solidFill>
+          <a:ln w="15875">
+            <a:solidFill>
+              <a:srgbClr val="E5E1D8"/>
+            </a:solidFill>
+          </a:ln>
+        </p:spPr>
+        <p:style>
+          <a:lnRef idx="1">
+            <a:schemeClr val="accent1"/>
+          </a:lnRef>
+          <a:fillRef idx="3">
+            <a:schemeClr val="accent1"/>
+          </a:fillRef>
+          <a:effectRef idx="2">
+            <a:schemeClr val="accent1"/>
+          </a:effectRef>
+          <a:fontRef idx="minor">
+            <a:schemeClr val="lt1"/>
+          </a:fontRef>
+        </p:style>
+        <p:txBody>
+          <a:bodyPr rtlCol="0" anchor="ctr"/>
+          <a:lstStyle/>
+          <a:p>
+            <a:pPr algn="ctr"/>
+          </a:p>
+        </p:txBody>
+      </p:sp>
+      <p:sp>
+        <p:nvSpPr>
+          <p:cNvPr id="5" name="TextBox 4"/>
+          <p:cNvSpPr txBox="1"/>
+          <p:nvPr/>
+        </p:nvSpPr>
+        <p:spPr>
+          <a:xfrm>
+            <a:off x="777240" y="1737360"/>
+            <a:ext cx="3108960" cy="457200"/>
+          </a:xfrm>
+          <a:prstGeom prst="rect">
+            <a:avLst/>
+          </a:prstGeom>
+          <a:noFill/>
+        </p:spPr>
+        <p:txBody>
+          <a:bodyPr wrap="square" lIns="0" rIns="0" anchor="t">
+            <a:noAutofit/>
+          </a:bodyPr>
+          <a:lstStyle/>
+          <a:p>
+            <a:pPr algn="ctr">
+              <a:lnSpc>
+                <a:spcPct val="115000"/>
+              </a:lnSpc>
+              <a:defRPr sz="1300" b="1">
+                <a:solidFill>
+                  <a:srgbClr val="111311"/>
+                </a:solidFill>
+              </a:defRPr>
+            </a:pPr>
+            <a:r>
+              <a:rPr>
+                <a:latin typeface="Meiryo"/>
+                <a:ea typeface="Meiryo"/>
+                <a:cs typeface="Meiryo"/>
+              </a:rPr>
+              <a:t>原因A：手順不明</a:t>
+            </a:r>
+          </a:p>
+        </p:txBody>
+      </p:sp>
+      <p:sp>
+        <p:nvSpPr>
+          <p:cNvPr id="6" name="TextBox 5"/>
+          <p:cNvSpPr txBox="1"/>
+          <p:nvPr/>
+        </p:nvSpPr>
+        <p:spPr>
+          <a:xfrm>
+            <a:off x="777240" y="2377440"/>
+            <a:ext cx="3108960" cy="1463040"/>
+          </a:xfrm>
+          <a:prstGeom prst="rect">
+            <a:avLst/>
+          </a:prstGeom>
+          <a:noFill/>
+        </p:spPr>
+        <p:txBody>
+          <a:bodyPr wrap="square" lIns="0" rIns="0" anchor="t">
+            <a:noAutofit/>
+          </a:bodyPr>
+          <a:lstStyle/>
+          <a:p>
+            <a:pPr algn="ctr">
+              <a:lnSpc>
+                <a:spcPct val="115000"/>
+              </a:lnSpc>
+              <a:defRPr sz="1200" b="0">
+                <a:solidFill>
+                  <a:srgbClr val="333333"/>
+                </a:solidFill>
+              </a:defRPr>
+            </a:pPr>
+            <a:r>
+              <a:rPr>
+                <a:latin typeface="Meiryo"/>
+                <a:ea typeface="Meiryo"/>
+                <a:cs typeface="Meiryo"/>
+              </a:rPr>
+              <a:t>53%は診断を試すも</a:t>
+            </a:r>
+            <a:br/>
+            <a:r>
+              <a:rPr>
+                <a:latin typeface="Meiryo"/>
+                <a:ea typeface="Meiryo"/>
+                <a:cs typeface="Meiryo"/>
+              </a:rPr>
+              <a:t>職種と結びつかない</a:t>
+            </a:r>
+          </a:p>
+        </p:txBody>
+      </p:sp>
+      <p:sp>
+        <p:nvSpPr>
+          <p:cNvPr id="7" name="TextBox 6"/>
+          <p:cNvSpPr txBox="1"/>
+          <p:nvPr/>
+        </p:nvSpPr>
+        <p:spPr>
+          <a:xfrm>
+            <a:off x="2103120" y="4617720"/>
+            <a:ext cx="457200" cy="457200"/>
+          </a:xfrm>
+          <a:prstGeom prst="rect">
+            <a:avLst/>
+          </a:prstGeom>
+          <a:noFill/>
+        </p:spPr>
+        <p:txBody>
+          <a:bodyPr wrap="square" lIns="0" rIns="0" anchor="t">
+            <a:noAutofit/>
+          </a:bodyPr>
+          <a:lstStyle/>
+          <a:p>
+            <a:pPr algn="ctr">
+              <a:lnSpc>
+                <a:spcPct val="115000"/>
+              </a:lnSpc>
+              <a:defRPr sz="1400" b="1">
+                <a:solidFill>
+                  <a:srgbClr val="B91C1C"/>
+                </a:solidFill>
+              </a:defRPr>
+            </a:pPr>
+            <a:r>
+              <a:rPr>
+                <a:latin typeface="Meiryo"/>
+                <a:ea typeface="Meiryo"/>
+                <a:cs typeface="Meiryo"/>
+              </a:rPr>
+              <a:t>▼</a:t>
+            </a:r>
+          </a:p>
+        </p:txBody>
+      </p:sp>
+      <p:sp>
+        <p:nvSpPr>
+          <p:cNvPr id="8" name="Rounded Rectangle 7"/>
+          <p:cNvSpPr/>
+          <p:nvPr/>
+        </p:nvSpPr>
+        <p:spPr>
+          <a:xfrm>
+            <a:off x="4297679" y="1508760"/>
+            <a:ext cx="3566160" cy="3017520"/>
+          </a:xfrm>
+          <a:prstGeom prst="roundRect">
+            <a:avLst>
+              <a:gd name="adj" fmla="val 12000"/>
+            </a:avLst>
+          </a:prstGeom>
+          <a:solidFill>
+            <a:srgbClr val="FFFFFF"/>
+          </a:solidFill>
+          <a:ln w="15875">
+            <a:solidFill>
+              <a:srgbClr val="E5E1D8"/>
+            </a:solidFill>
+          </a:ln>
+        </p:spPr>
+        <p:style>
+          <a:lnRef idx="1">
+            <a:schemeClr val="accent1"/>
+          </a:lnRef>
+          <a:fillRef idx="3">
+            <a:schemeClr val="accent1"/>
+          </a:fillRef>
+          <a:effectRef idx="2">
+            <a:schemeClr val="accent1"/>
+          </a:effectRef>
+          <a:fontRef idx="minor">
+            <a:schemeClr val="lt1"/>
+          </a:fontRef>
+        </p:style>
+        <p:txBody>
+          <a:bodyPr rtlCol="0" anchor="ctr"/>
+          <a:lstStyle/>
+          <a:p>
+            <a:pPr algn="ctr"/>
+          </a:p>
+        </p:txBody>
+      </p:sp>
+      <p:sp>
+        <p:nvSpPr>
+          <p:cNvPr id="9" name="TextBox 8"/>
+          <p:cNvSpPr txBox="1"/>
+          <p:nvPr/>
+        </p:nvSpPr>
+        <p:spPr>
+          <a:xfrm>
+            <a:off x="4526279" y="1737360"/>
+            <a:ext cx="3108960" cy="457200"/>
+          </a:xfrm>
+          <a:prstGeom prst="rect">
+            <a:avLst/>
+          </a:prstGeom>
+          <a:noFill/>
+        </p:spPr>
+        <p:txBody>
+          <a:bodyPr wrap="square" lIns="0" rIns="0" anchor="t">
+            <a:noAutofit/>
+          </a:bodyPr>
+          <a:lstStyle/>
+          <a:p>
+            <a:pPr algn="ctr">
+              <a:lnSpc>
+                <a:spcPct val="115000"/>
+              </a:lnSpc>
+              <a:defRPr sz="1300" b="1">
+                <a:solidFill>
+                  <a:srgbClr val="111311"/>
+                </a:solidFill>
+              </a:defRPr>
+            </a:pPr>
+            <a:r>
+              <a:rPr>
+                <a:latin typeface="Meiryo"/>
+                <a:ea typeface="Meiryo"/>
+                <a:cs typeface="Meiryo"/>
+              </a:rPr>
+              <a:t>原因B：ゴール不明</a:t>
+            </a:r>
+          </a:p>
+        </p:txBody>
+      </p:sp>
+      <p:sp>
+        <p:nvSpPr>
+          <p:cNvPr id="10" name="TextBox 9"/>
+          <p:cNvSpPr txBox="1"/>
+          <p:nvPr/>
+        </p:nvSpPr>
+        <p:spPr>
+          <a:xfrm>
+            <a:off x="4526279" y="2377440"/>
+            <a:ext cx="3108960" cy="1463040"/>
+          </a:xfrm>
+          <a:prstGeom prst="rect">
+            <a:avLst/>
+          </a:prstGeom>
+          <a:noFill/>
+        </p:spPr>
+        <p:txBody>
+          <a:bodyPr wrap="square" lIns="0" rIns="0" anchor="t">
+            <a:noAutofit/>
+          </a:bodyPr>
+          <a:lstStyle/>
+          <a:p>
+            <a:pPr algn="ctr">
+              <a:lnSpc>
+                <a:spcPct val="115000"/>
+              </a:lnSpc>
+              <a:defRPr sz="1200" b="0">
+                <a:solidFill>
+                  <a:srgbClr val="333333"/>
+                </a:solidFill>
+              </a:defRPr>
+            </a:pPr>
+            <a:r>
+              <a:rPr>
+                <a:latin typeface="Meiryo"/>
+                <a:ea typeface="Meiryo"/>
+                <a:cs typeface="Meiryo"/>
+              </a:rPr>
+              <a:t>信頼できる30.5%</a:t>
+            </a:r>
+            <a:br/>
+            <a:r>
+              <a:rPr>
+                <a:latin typeface="Meiryo"/>
+                <a:ea typeface="Meiryo"/>
+                <a:cs typeface="Meiryo"/>
+              </a:rPr>
+              <a:t>保留42.0%で判断停止</a:t>
+            </a:r>
+          </a:p>
+        </p:txBody>
+      </p:sp>
+      <p:sp>
+        <p:nvSpPr>
+          <p:cNvPr id="11" name="TextBox 10"/>
+          <p:cNvSpPr txBox="1"/>
+          <p:nvPr/>
+        </p:nvSpPr>
+        <p:spPr>
+          <a:xfrm>
+            <a:off x="5852159" y="4617720"/>
+            <a:ext cx="457200" cy="457200"/>
+          </a:xfrm>
+          <a:prstGeom prst="rect">
+            <a:avLst/>
+          </a:prstGeom>
+          <a:noFill/>
+        </p:spPr>
+        <p:txBody>
+          <a:bodyPr wrap="square" lIns="0" rIns="0" anchor="t">
+            <a:noAutofit/>
+          </a:bodyPr>
+          <a:lstStyle/>
+          <a:p>
+            <a:pPr algn="ctr">
+              <a:lnSpc>
+                <a:spcPct val="115000"/>
+              </a:lnSpc>
+              <a:defRPr sz="1400" b="1">
+                <a:solidFill>
+                  <a:srgbClr val="B91C1C"/>
+                </a:solidFill>
+              </a:defRPr>
+            </a:pPr>
+            <a:r>
+              <a:rPr>
+                <a:latin typeface="Meiryo"/>
+                <a:ea typeface="Meiryo"/>
+                <a:cs typeface="Meiryo"/>
+              </a:rPr>
+              <a:t>▼</a:t>
+            </a:r>
+          </a:p>
+        </p:txBody>
+      </p:sp>
+      <p:sp>
+        <p:nvSpPr>
+          <p:cNvPr id="12" name="Rounded Rectangle 11"/>
+          <p:cNvSpPr/>
+          <p:nvPr/>
+        </p:nvSpPr>
+        <p:spPr>
+          <a:xfrm>
+            <a:off x="8046719" y="1508760"/>
+            <a:ext cx="3566160" cy="3017520"/>
+          </a:xfrm>
+          <a:prstGeom prst="roundRect">
+            <a:avLst>
+              <a:gd name="adj" fmla="val 12000"/>
+            </a:avLst>
+          </a:prstGeom>
+          <a:solidFill>
+            <a:srgbClr val="FFFFFF"/>
+          </a:solidFill>
+          <a:ln w="15875">
+            <a:solidFill>
+              <a:srgbClr val="E5E1D8"/>
+            </a:solidFill>
+          </a:ln>
+        </p:spPr>
+        <p:style>
+          <a:lnRef idx="1">
+            <a:schemeClr val="accent1"/>
+          </a:lnRef>
+          <a:fillRef idx="3">
+            <a:schemeClr val="accent1"/>
+          </a:fillRef>
+          <a:effectRef idx="2">
+            <a:schemeClr val="accent1"/>
+          </a:effectRef>
+          <a:fontRef idx="minor">
+            <a:schemeClr val="lt1"/>
+          </a:fontRef>
+        </p:style>
+        <p:txBody>
+          <a:bodyPr rtlCol="0" anchor="ctr"/>
+          <a:lstStyle/>
+          <a:p>
+            <a:pPr algn="ctr"/>
+          </a:p>
+        </p:txBody>
+      </p:sp>
+      <p:sp>
+        <p:nvSpPr>
+          <p:cNvPr id="13" name="TextBox 12"/>
+          <p:cNvSpPr txBox="1"/>
+          <p:nvPr/>
+        </p:nvSpPr>
+        <p:spPr>
+          <a:xfrm>
+            <a:off x="8275319" y="1737360"/>
+            <a:ext cx="3108960" cy="457200"/>
+          </a:xfrm>
+          <a:prstGeom prst="rect">
+            <a:avLst/>
+          </a:prstGeom>
+          <a:noFill/>
+        </p:spPr>
+        <p:txBody>
+          <a:bodyPr wrap="square" lIns="0" rIns="0" anchor="t">
+            <a:noAutofit/>
+          </a:bodyPr>
+          <a:lstStyle/>
+          <a:p>
+            <a:pPr algn="ctr">
+              <a:lnSpc>
+                <a:spcPct val="115000"/>
+              </a:lnSpc>
+              <a:defRPr sz="1300" b="1">
+                <a:solidFill>
+                  <a:srgbClr val="111311"/>
+                </a:solidFill>
+              </a:defRPr>
+            </a:pPr>
+            <a:r>
+              <a:rPr>
+                <a:latin typeface="Meiryo"/>
+                <a:ea typeface="Meiryo"/>
+                <a:cs typeface="Meiryo"/>
+              </a:rPr>
+              <a:t>原因C：時期遅れ</a:t>
+            </a:r>
+          </a:p>
+        </p:txBody>
+      </p:sp>
+      <p:sp>
+        <p:nvSpPr>
+          <p:cNvPr id="14" name="TextBox 13"/>
+          <p:cNvSpPr txBox="1"/>
+          <p:nvPr/>
+        </p:nvSpPr>
+        <p:spPr>
+          <a:xfrm>
+            <a:off x="8275319" y="2377440"/>
+            <a:ext cx="3108960" cy="1463040"/>
+          </a:xfrm>
+          <a:prstGeom prst="rect">
+            <a:avLst/>
+          </a:prstGeom>
+          <a:noFill/>
+        </p:spPr>
+        <p:txBody>
+          <a:bodyPr wrap="square" lIns="0" rIns="0" anchor="t">
+            <a:noAutofit/>
+          </a:bodyPr>
+          <a:lstStyle/>
+          <a:p>
+            <a:pPr algn="ctr">
+              <a:lnSpc>
+                <a:spcPct val="115000"/>
+              </a:lnSpc>
+              <a:defRPr sz="1200" b="0">
+                <a:solidFill>
+                  <a:srgbClr val="333333"/>
+                </a:solidFill>
+              </a:defRPr>
+            </a:pPr>
+            <a:r>
+              <a:rPr>
+                <a:latin typeface="Meiryo"/>
+                <a:ea typeface="Meiryo"/>
+                <a:cs typeface="Meiryo"/>
+              </a:rPr>
+              <a:t>開始35%のみ</a:t>
+            </a:r>
+            <a:br/>
+            <a:r>
+              <a:rPr>
+                <a:latin typeface="Meiryo"/>
+                <a:ea typeface="Meiryo"/>
+                <a:cs typeface="Meiryo"/>
+              </a:rPr>
+              <a:t>秋に35.2%が逆戻り</a:t>
+            </a:r>
+          </a:p>
+        </p:txBody>
+      </p:sp>
+      <p:sp>
+        <p:nvSpPr>
+          <p:cNvPr id="15" name="TextBox 14"/>
+          <p:cNvSpPr txBox="1"/>
+          <p:nvPr/>
+        </p:nvSpPr>
+        <p:spPr>
+          <a:xfrm>
+            <a:off x="9601199" y="4617720"/>
+            <a:ext cx="457200" cy="457200"/>
+          </a:xfrm>
+          <a:prstGeom prst="rect">
+            <a:avLst/>
+          </a:prstGeom>
+          <a:noFill/>
+        </p:spPr>
+        <p:txBody>
+          <a:bodyPr wrap="square" lIns="0" rIns="0" anchor="t">
+            <a:noAutofit/>
+          </a:bodyPr>
+          <a:lstStyle/>
+          <a:p>
+            <a:pPr algn="ctr">
+              <a:lnSpc>
+                <a:spcPct val="115000"/>
+              </a:lnSpc>
+              <a:defRPr sz="1400" b="1">
+                <a:solidFill>
+                  <a:srgbClr val="B91C1C"/>
+                </a:solidFill>
+              </a:defRPr>
+            </a:pPr>
+            <a:r>
+              <a:rPr>
+                <a:latin typeface="Meiryo"/>
+                <a:ea typeface="Meiryo"/>
+                <a:cs typeface="Meiryo"/>
+              </a:rPr>
+              <a:t>▼</a:t>
+            </a:r>
+          </a:p>
+        </p:txBody>
+      </p:sp>
+      <p:sp>
+        <p:nvSpPr>
+          <p:cNvPr id="16" name="Rounded Rectangle 15"/>
+          <p:cNvSpPr/>
+          <p:nvPr/>
+        </p:nvSpPr>
+        <p:spPr>
+          <a:xfrm>
+            <a:off x="548640" y="5166360"/>
+            <a:ext cx="11064240" cy="868680"/>
           </a:xfrm>
           <a:prstGeom prst="roundRect">
             <a:avLst>
@@ -6609,14 +7408,14 @@
       </p:sp>
       <p:sp>
         <p:nvSpPr>
-          <p:cNvPr id="5" name="TextBox 4"/>
+          <p:cNvPr id="17" name="TextBox 16"/>
           <p:cNvSpPr txBox="1"/>
           <p:nvPr/>
         </p:nvSpPr>
         <p:spPr>
           <a:xfrm>
-            <a:off x="868680" y="1536192"/>
-            <a:ext cx="2926080" cy="411480"/>
+            <a:off x="822960" y="5303520"/>
+            <a:ext cx="10515600" cy="594360"/>
           </a:xfrm>
           <a:prstGeom prst="rect">
             <a:avLst/>
@@ -6633,668 +7432,19 @@
               <a:lnSpc>
                 <a:spcPct val="115000"/>
               </a:lnSpc>
-              <a:defRPr sz="1200" b="1">
+              <a:defRPr sz="1300" b="1">
                 <a:solidFill>
                   <a:srgbClr val="FFFFFF"/>
                 </a:solidFill>
               </a:defRPr>
             </a:pPr>
-          </a:p>
-        </p:txBody>
-      </p:sp>
-      <p:sp>
-        <p:nvSpPr>
-          <p:cNvPr id="6" name="TextBox 5"/>
-          <p:cNvSpPr txBox="1"/>
-          <p:nvPr/>
-        </p:nvSpPr>
-        <p:spPr>
-          <a:xfrm>
-            <a:off x="4023360" y="1536192"/>
-            <a:ext cx="3383280" cy="411480"/>
-          </a:xfrm>
-          <a:prstGeom prst="rect">
-            <a:avLst/>
-          </a:prstGeom>
-          <a:noFill/>
-        </p:spPr>
-        <p:txBody>
-          <a:bodyPr wrap="square" lIns="0" rIns="0" anchor="t">
-            <a:noAutofit/>
-          </a:bodyPr>
-          <a:lstStyle/>
-          <a:p>
-            <a:pPr algn="ctr">
-              <a:lnSpc>
-                <a:spcPct val="115000"/>
-              </a:lnSpc>
-              <a:defRPr sz="1200" b="1">
-                <a:solidFill>
-                  <a:srgbClr val="FFFFFF"/>
-                </a:solidFill>
-              </a:defRPr>
-            </a:pPr>
-            <a:r>
-              <a:rPr>
-                <a:latin typeface="Meiryo"/>
-                <a:ea typeface="Meiryo"/>
-                <a:cs typeface="Meiryo"/>
-              </a:rPr>
-              <a:t>短期（選考期）</a:t>
-            </a:r>
-          </a:p>
-        </p:txBody>
-      </p:sp>
-      <p:sp>
-        <p:nvSpPr>
-          <p:cNvPr id="7" name="TextBox 6"/>
-          <p:cNvSpPr txBox="1"/>
-          <p:nvPr/>
-        </p:nvSpPr>
-        <p:spPr>
-          <a:xfrm>
-            <a:off x="7680960" y="1536192"/>
-            <a:ext cx="3383280" cy="411480"/>
-          </a:xfrm>
-          <a:prstGeom prst="rect">
-            <a:avLst/>
-          </a:prstGeom>
-          <a:noFill/>
-        </p:spPr>
-        <p:txBody>
-          <a:bodyPr wrap="square" lIns="0" rIns="0" anchor="t">
-            <a:noAutofit/>
-          </a:bodyPr>
-          <a:lstStyle/>
-          <a:p>
-            <a:pPr algn="ctr">
-              <a:lnSpc>
-                <a:spcPct val="115000"/>
-              </a:lnSpc>
-              <a:defRPr sz="1200" b="1">
-                <a:solidFill>
-                  <a:srgbClr val="FFFFFF"/>
-                </a:solidFill>
-              </a:defRPr>
-            </a:pPr>
-            <a:r>
-              <a:rPr>
-                <a:latin typeface="Meiryo"/>
-                <a:ea typeface="Meiryo"/>
-                <a:cs typeface="Meiryo"/>
-              </a:rPr>
-              <a:t>長期（入社後）</a:t>
-            </a:r>
-          </a:p>
-        </p:txBody>
-      </p:sp>
-      <p:sp>
-        <p:nvSpPr>
-          <p:cNvPr id="8" name="Rounded Rectangle 7"/>
-          <p:cNvSpPr/>
-          <p:nvPr/>
-        </p:nvSpPr>
-        <p:spPr>
-          <a:xfrm>
-            <a:off x="548640" y="2148840"/>
-            <a:ext cx="11064240" cy="960120"/>
-          </a:xfrm>
-          <a:prstGeom prst="roundRect">
-            <a:avLst>
-              <a:gd name="adj" fmla="val 12000"/>
-            </a:avLst>
-          </a:prstGeom>
-          <a:solidFill>
-            <a:srgbClr val="FFFFFF"/>
-          </a:solidFill>
-          <a:ln w="15875">
-            <a:solidFill>
-              <a:srgbClr val="E5E1D8"/>
-            </a:solidFill>
-          </a:ln>
-        </p:spPr>
-        <p:style>
-          <a:lnRef idx="1">
-            <a:schemeClr val="accent1"/>
-          </a:lnRef>
-          <a:fillRef idx="3">
-            <a:schemeClr val="accent1"/>
-          </a:fillRef>
-          <a:effectRef idx="2">
-            <a:schemeClr val="accent1"/>
-          </a:effectRef>
-          <a:fontRef idx="minor">
-            <a:schemeClr val="lt1"/>
-          </a:fontRef>
-        </p:style>
-        <p:txBody>
-          <a:bodyPr rtlCol="0" anchor="ctr"/>
-          <a:lstStyle/>
-          <a:p>
-            <a:pPr algn="ctr"/>
-          </a:p>
-        </p:txBody>
-      </p:sp>
-      <p:sp>
-        <p:nvSpPr>
-          <p:cNvPr id="9" name="TextBox 8"/>
-          <p:cNvSpPr txBox="1"/>
-          <p:nvPr/>
-        </p:nvSpPr>
-        <p:spPr>
-          <a:xfrm>
-            <a:off x="868680" y="2258568"/>
-            <a:ext cx="2926080" cy="731520"/>
-          </a:xfrm>
-          <a:prstGeom prst="rect">
-            <a:avLst/>
-          </a:prstGeom>
-          <a:noFill/>
-        </p:spPr>
-        <p:txBody>
-          <a:bodyPr wrap="square" lIns="0" rIns="0" anchor="t">
-            <a:noAutofit/>
-          </a:bodyPr>
-          <a:lstStyle/>
-          <a:p>
-            <a:pPr algn="ctr">
-              <a:lnSpc>
-                <a:spcPct val="115000"/>
-              </a:lnSpc>
-              <a:defRPr sz="1300" b="1">
-                <a:solidFill>
-                  <a:srgbClr val="111311"/>
-                </a:solidFill>
-              </a:defRPr>
-            </a:pPr>
-            <a:r>
-              <a:rPr>
-                <a:latin typeface="Meiryo"/>
-                <a:ea typeface="Meiryo"/>
-                <a:cs typeface="Meiryo"/>
-              </a:rPr>
-              <a:t>学生</a:t>
-            </a:r>
-          </a:p>
-        </p:txBody>
-      </p:sp>
-      <p:sp>
-        <p:nvSpPr>
-          <p:cNvPr id="10" name="TextBox 9"/>
-          <p:cNvSpPr txBox="1"/>
-          <p:nvPr/>
-        </p:nvSpPr>
-        <p:spPr>
-          <a:xfrm>
-            <a:off x="4023360" y="2258568"/>
-            <a:ext cx="3383280" cy="731520"/>
-          </a:xfrm>
-          <a:prstGeom prst="rect">
-            <a:avLst/>
-          </a:prstGeom>
-          <a:noFill/>
-        </p:spPr>
-        <p:txBody>
-          <a:bodyPr wrap="square" lIns="0" rIns="0" anchor="t">
-            <a:noAutofit/>
-          </a:bodyPr>
-          <a:lstStyle/>
-          <a:p>
-            <a:pPr algn="ctr">
-              <a:lnSpc>
-                <a:spcPct val="115000"/>
-              </a:lnSpc>
-              <a:defRPr sz="1100" b="0">
-                <a:solidFill>
-                  <a:srgbClr val="111311"/>
-                </a:solidFill>
-              </a:defRPr>
-            </a:pPr>
-            <a:r>
-              <a:rPr>
-                <a:latin typeface="Meiryo"/>
-                <a:ea typeface="Meiryo"/>
-                <a:cs typeface="Meiryo"/>
-              </a:rPr>
-              <a:t>自信なき応募・手戻り</a:t>
-            </a:r>
-          </a:p>
-        </p:txBody>
-      </p:sp>
-      <p:sp>
-        <p:nvSpPr>
-          <p:cNvPr id="11" name="TextBox 10"/>
-          <p:cNvSpPr txBox="1"/>
-          <p:nvPr/>
-        </p:nvSpPr>
-        <p:spPr>
-          <a:xfrm>
-            <a:off x="7680960" y="2258568"/>
-            <a:ext cx="3383280" cy="731520"/>
-          </a:xfrm>
-          <a:prstGeom prst="rect">
-            <a:avLst/>
-          </a:prstGeom>
-          <a:noFill/>
-        </p:spPr>
-        <p:txBody>
-          <a:bodyPr wrap="square" lIns="0" rIns="0" anchor="t">
-            <a:noAutofit/>
-          </a:bodyPr>
-          <a:lstStyle/>
-          <a:p>
-            <a:pPr algn="ctr">
-              <a:lnSpc>
-                <a:spcPct val="115000"/>
-              </a:lnSpc>
-              <a:defRPr sz="1100" b="0">
-                <a:solidFill>
-                  <a:srgbClr val="111311"/>
-                </a:solidFill>
-              </a:defRPr>
-            </a:pPr>
-            <a:r>
-              <a:rPr>
-                <a:latin typeface="Meiryo"/>
-                <a:ea typeface="Meiryo"/>
-                <a:cs typeface="Meiryo"/>
-              </a:rPr>
-              <a:t>納得低下・ミスマッチ</a:t>
-            </a:r>
-          </a:p>
-        </p:txBody>
-      </p:sp>
-      <p:sp>
-        <p:nvSpPr>
-          <p:cNvPr id="12" name="Rounded Rectangle 11"/>
-          <p:cNvSpPr/>
-          <p:nvPr/>
-        </p:nvSpPr>
-        <p:spPr>
-          <a:xfrm>
-            <a:off x="548640" y="3227832"/>
-            <a:ext cx="11064240" cy="960120"/>
-          </a:xfrm>
-          <a:prstGeom prst="roundRect">
-            <a:avLst>
-              <a:gd name="adj" fmla="val 12000"/>
-            </a:avLst>
-          </a:prstGeom>
-          <a:solidFill>
-            <a:srgbClr val="FFFFFF"/>
-          </a:solidFill>
-          <a:ln w="15875">
-            <a:solidFill>
-              <a:srgbClr val="E5E1D8"/>
-            </a:solidFill>
-          </a:ln>
-        </p:spPr>
-        <p:style>
-          <a:lnRef idx="1">
-            <a:schemeClr val="accent1"/>
-          </a:lnRef>
-          <a:fillRef idx="3">
-            <a:schemeClr val="accent1"/>
-          </a:fillRef>
-          <a:effectRef idx="2">
-            <a:schemeClr val="accent1"/>
-          </a:effectRef>
-          <a:fontRef idx="minor">
-            <a:schemeClr val="lt1"/>
-          </a:fontRef>
-        </p:style>
-        <p:txBody>
-          <a:bodyPr rtlCol="0" anchor="ctr"/>
-          <a:lstStyle/>
-          <a:p>
-            <a:pPr algn="ctr"/>
-          </a:p>
-        </p:txBody>
-      </p:sp>
-      <p:sp>
-        <p:nvSpPr>
-          <p:cNvPr id="13" name="TextBox 12"/>
-          <p:cNvSpPr txBox="1"/>
-          <p:nvPr/>
-        </p:nvSpPr>
-        <p:spPr>
-          <a:xfrm>
-            <a:off x="868680" y="3337560"/>
-            <a:ext cx="2926080" cy="731520"/>
-          </a:xfrm>
-          <a:prstGeom prst="rect">
-            <a:avLst/>
-          </a:prstGeom>
-          <a:noFill/>
-        </p:spPr>
-        <p:txBody>
-          <a:bodyPr wrap="square" lIns="0" rIns="0" anchor="t">
-            <a:noAutofit/>
-          </a:bodyPr>
-          <a:lstStyle/>
-          <a:p>
-            <a:pPr algn="ctr">
-              <a:lnSpc>
-                <a:spcPct val="115000"/>
-              </a:lnSpc>
-              <a:defRPr sz="1300" b="1">
-                <a:solidFill>
-                  <a:srgbClr val="111311"/>
-                </a:solidFill>
-              </a:defRPr>
-            </a:pPr>
-            <a:r>
-              <a:rPr>
-                <a:latin typeface="Meiryo"/>
-                <a:ea typeface="Meiryo"/>
-                <a:cs typeface="Meiryo"/>
-              </a:rPr>
-              <a:t>企業</a:t>
-            </a:r>
-          </a:p>
-        </p:txBody>
-      </p:sp>
-      <p:sp>
-        <p:nvSpPr>
-          <p:cNvPr id="14" name="TextBox 13"/>
-          <p:cNvSpPr txBox="1"/>
-          <p:nvPr/>
-        </p:nvSpPr>
-        <p:spPr>
-          <a:xfrm>
-            <a:off x="4023360" y="3337560"/>
-            <a:ext cx="3383280" cy="731520"/>
-          </a:xfrm>
-          <a:prstGeom prst="rect">
-            <a:avLst/>
-          </a:prstGeom>
-          <a:noFill/>
-        </p:spPr>
-        <p:txBody>
-          <a:bodyPr wrap="square" lIns="0" rIns="0" anchor="t">
-            <a:noAutofit/>
-          </a:bodyPr>
-          <a:lstStyle/>
-          <a:p>
-            <a:pPr algn="ctr">
-              <a:lnSpc>
-                <a:spcPct val="115000"/>
-              </a:lnSpc>
-              <a:defRPr sz="1100" b="0">
-                <a:solidFill>
-                  <a:srgbClr val="111311"/>
-                </a:solidFill>
-              </a:defRPr>
-            </a:pPr>
-            <a:r>
-              <a:rPr>
-                <a:latin typeface="Meiryo"/>
-                <a:ea typeface="Meiryo"/>
-                <a:cs typeface="Meiryo"/>
-              </a:rPr>
-              <a:t>人柄93.8%を評価不能</a:t>
-            </a:r>
-          </a:p>
-        </p:txBody>
-      </p:sp>
-      <p:sp>
-        <p:nvSpPr>
-          <p:cNvPr id="15" name="TextBox 14"/>
-          <p:cNvSpPr txBox="1"/>
-          <p:nvPr/>
-        </p:nvSpPr>
-        <p:spPr>
-          <a:xfrm>
-            <a:off x="7680960" y="3337560"/>
-            <a:ext cx="3383280" cy="731520"/>
-          </a:xfrm>
-          <a:prstGeom prst="rect">
-            <a:avLst/>
-          </a:prstGeom>
-          <a:noFill/>
-        </p:spPr>
-        <p:txBody>
-          <a:bodyPr wrap="square" lIns="0" rIns="0" anchor="t">
-            <a:noAutofit/>
-          </a:bodyPr>
-          <a:lstStyle/>
-          <a:p>
-            <a:pPr algn="ctr">
-              <a:lnSpc>
-                <a:spcPct val="115000"/>
-              </a:lnSpc>
-              <a:defRPr sz="1100" b="0">
-                <a:solidFill>
-                  <a:srgbClr val="111311"/>
-                </a:solidFill>
-              </a:defRPr>
-            </a:pPr>
-            <a:r>
-              <a:rPr>
-                <a:latin typeface="Meiryo"/>
-                <a:ea typeface="Meiryo"/>
-                <a:cs typeface="Meiryo"/>
-              </a:rPr>
-              <a:t>採用・定着コスト増</a:t>
-            </a:r>
-          </a:p>
-        </p:txBody>
-      </p:sp>
-      <p:sp>
-        <p:nvSpPr>
-          <p:cNvPr id="16" name="Rounded Rectangle 15"/>
-          <p:cNvSpPr/>
-          <p:nvPr/>
-        </p:nvSpPr>
-        <p:spPr>
-          <a:xfrm>
-            <a:off x="548640" y="4306824"/>
-            <a:ext cx="11064240" cy="960120"/>
-          </a:xfrm>
-          <a:prstGeom prst="roundRect">
-            <a:avLst>
-              <a:gd name="adj" fmla="val 12000"/>
-            </a:avLst>
-          </a:prstGeom>
-          <a:solidFill>
-            <a:srgbClr val="FFFFFF"/>
-          </a:solidFill>
-          <a:ln w="15875">
-            <a:solidFill>
-              <a:srgbClr val="E5E1D8"/>
-            </a:solidFill>
-          </a:ln>
-        </p:spPr>
-        <p:style>
-          <a:lnRef idx="1">
-            <a:schemeClr val="accent1"/>
-          </a:lnRef>
-          <a:fillRef idx="3">
-            <a:schemeClr val="accent1"/>
-          </a:fillRef>
-          <a:effectRef idx="2">
-            <a:schemeClr val="accent1"/>
-          </a:effectRef>
-          <a:fontRef idx="minor">
-            <a:schemeClr val="lt1"/>
-          </a:fontRef>
-        </p:style>
-        <p:txBody>
-          <a:bodyPr rtlCol="0" anchor="ctr"/>
-          <a:lstStyle/>
-          <a:p>
-            <a:pPr algn="ctr"/>
-          </a:p>
-        </p:txBody>
-      </p:sp>
-      <p:sp>
-        <p:nvSpPr>
-          <p:cNvPr id="17" name="TextBox 16"/>
-          <p:cNvSpPr txBox="1"/>
-          <p:nvPr/>
-        </p:nvSpPr>
-        <p:spPr>
-          <a:xfrm>
-            <a:off x="868680" y="4416552"/>
-            <a:ext cx="2926080" cy="731520"/>
-          </a:xfrm>
-          <a:prstGeom prst="rect">
-            <a:avLst/>
-          </a:prstGeom>
-          <a:noFill/>
-        </p:spPr>
-        <p:txBody>
-          <a:bodyPr wrap="square" lIns="0" rIns="0" anchor="t">
-            <a:noAutofit/>
-          </a:bodyPr>
-          <a:lstStyle/>
-          <a:p>
-            <a:pPr algn="ctr">
-              <a:lnSpc>
-                <a:spcPct val="115000"/>
-              </a:lnSpc>
-              <a:defRPr sz="1300" b="1">
-                <a:solidFill>
-                  <a:srgbClr val="111311"/>
-                </a:solidFill>
-              </a:defRPr>
-            </a:pPr>
-            <a:r>
-              <a:rPr>
-                <a:latin typeface="Meiryo"/>
-                <a:ea typeface="Meiryo"/>
-                <a:cs typeface="Meiryo"/>
-              </a:rPr>
-              <a:t>社会</a:t>
-            </a:r>
-          </a:p>
-        </p:txBody>
-      </p:sp>
-      <p:sp>
-        <p:nvSpPr>
-          <p:cNvPr id="18" name="TextBox 17"/>
-          <p:cNvSpPr txBox="1"/>
-          <p:nvPr/>
-        </p:nvSpPr>
-        <p:spPr>
-          <a:xfrm>
-            <a:off x="4023360" y="4416552"/>
-            <a:ext cx="3383280" cy="731520"/>
-          </a:xfrm>
-          <a:prstGeom prst="rect">
-            <a:avLst/>
-          </a:prstGeom>
-          <a:noFill/>
-        </p:spPr>
-        <p:txBody>
-          <a:bodyPr wrap="square" lIns="0" rIns="0" anchor="t">
-            <a:noAutofit/>
-          </a:bodyPr>
-          <a:lstStyle/>
-          <a:p>
-            <a:pPr algn="ctr">
-              <a:lnSpc>
-                <a:spcPct val="115000"/>
-              </a:lnSpc>
-              <a:defRPr sz="1100" b="0">
-                <a:solidFill>
-                  <a:srgbClr val="111311"/>
-                </a:solidFill>
-              </a:defRPr>
-            </a:pPr>
-            <a:r>
-              <a:rPr>
-                <a:latin typeface="Meiryo"/>
-                <a:ea typeface="Meiryo"/>
-                <a:cs typeface="Meiryo"/>
-              </a:rPr>
-              <a:t>支援の手戻り</a:t>
-            </a:r>
-          </a:p>
-        </p:txBody>
-      </p:sp>
-      <p:sp>
-        <p:nvSpPr>
-          <p:cNvPr id="19" name="TextBox 18"/>
-          <p:cNvSpPr txBox="1"/>
-          <p:nvPr/>
-        </p:nvSpPr>
-        <p:spPr>
-          <a:xfrm>
-            <a:off x="7680960" y="4416552"/>
-            <a:ext cx="3383280" cy="731520"/>
-          </a:xfrm>
-          <a:prstGeom prst="rect">
-            <a:avLst/>
-          </a:prstGeom>
-          <a:noFill/>
-        </p:spPr>
-        <p:txBody>
-          <a:bodyPr wrap="square" lIns="0" rIns="0" anchor="t">
-            <a:noAutofit/>
-          </a:bodyPr>
-          <a:lstStyle/>
-          <a:p>
-            <a:pPr algn="ctr">
-              <a:lnSpc>
-                <a:spcPct val="115000"/>
-              </a:lnSpc>
-              <a:defRPr sz="1100" b="0">
-                <a:solidFill>
-                  <a:srgbClr val="111311"/>
-                </a:solidFill>
-              </a:defRPr>
-            </a:pPr>
-            <a:r>
-              <a:rPr>
-                <a:latin typeface="Meiryo"/>
-                <a:ea typeface="Meiryo"/>
-                <a:cs typeface="Meiryo"/>
-              </a:rPr>
-              <a:t>早期離職・40%ギャップ</a:t>
-            </a:r>
-          </a:p>
-        </p:txBody>
-      </p:sp>
-      <p:sp>
-        <p:nvSpPr>
-          <p:cNvPr id="20" name="TextBox 19"/>
-          <p:cNvSpPr txBox="1"/>
-          <p:nvPr/>
-        </p:nvSpPr>
-        <p:spPr>
-          <a:xfrm>
-            <a:off x="548640" y="5486400"/>
-            <a:ext cx="11064240" cy="548640"/>
-          </a:xfrm>
-          <a:prstGeom prst="rect">
-            <a:avLst/>
-          </a:prstGeom>
-          <a:noFill/>
-        </p:spPr>
-        <p:txBody>
-          <a:bodyPr wrap="square" lIns="0" rIns="0" anchor="t">
-            <a:noAutofit/>
-          </a:bodyPr>
-          <a:lstStyle/>
-          <a:p>
-            <a:pPr algn="ctr">
-              <a:lnSpc>
-                <a:spcPct val="115000"/>
-              </a:lnSpc>
-              <a:defRPr sz="1100" b="0">
-                <a:solidFill>
-                  <a:srgbClr val="6B6F6B"/>
-                </a:solidFill>
-              </a:defRPr>
-            </a:pPr>
-            <a:r>
-              <a:rPr>
-                <a:latin typeface="Meiryo"/>
-                <a:ea typeface="Meiryo"/>
-                <a:cs typeface="Meiryo"/>
-              </a:rPr>
-              <a:t>だから解決に社会的価値がある ／ 出典：白書93.8%・社会人40%・学情60.7%</a:t>
+            <a:r>
+              <a:rPr>
+                <a:latin typeface="Meiryo"/>
+                <a:ea typeface="Meiryo"/>
+                <a:cs typeface="Meiryo"/>
+              </a:rPr>
+              <a:t>→ 土台ゼロで選考 → 落ちる → 戻る の往復で時間と自信を失う</a:t>
             </a:r>
           </a:p>
         </p:txBody>
@@ -7363,7 +7513,858 @@
                 <a:ea typeface="Meiryo"/>
                 <a:cs typeface="Meiryo"/>
               </a:rPr>
-              <a:t>(06) まとめ &amp; 次へ</a:t>
+              <a:t>(06) 課題分析② — 放置すると誰が損するか</a:t>
+            </a:r>
+          </a:p>
+        </p:txBody>
+      </p:sp>
+      <p:sp>
+        <p:nvSpPr>
+          <p:cNvPr id="3" name="TextBox 2"/>
+          <p:cNvSpPr txBox="1"/>
+          <p:nvPr/>
+        </p:nvSpPr>
+        <p:spPr>
+          <a:xfrm>
+            <a:off x="548640" y="594360"/>
+            <a:ext cx="11064240" cy="731520"/>
+          </a:xfrm>
+          <a:prstGeom prst="rect">
+            <a:avLst/>
+          </a:prstGeom>
+          <a:noFill/>
+        </p:spPr>
+        <p:txBody>
+          <a:bodyPr wrap="square" lIns="0" rIns="0" anchor="t">
+            <a:noAutofit/>
+          </a:bodyPr>
+          <a:lstStyle/>
+          <a:p>
+            <a:pPr algn="l">
+              <a:lnSpc>
+                <a:spcPct val="115000"/>
+              </a:lnSpc>
+              <a:defRPr sz="3000" b="1">
+                <a:solidFill>
+                  <a:srgbClr val="111311"/>
+                </a:solidFill>
+              </a:defRPr>
+            </a:pPr>
+            <a:r>
+              <a:rPr>
+                <a:latin typeface="Meiryo"/>
+                <a:ea typeface="Meiryo"/>
+                <a:cs typeface="Meiryo"/>
+              </a:rPr>
+              <a:t>三者損失マトリクス。</a:t>
+            </a:r>
+          </a:p>
+        </p:txBody>
+      </p:sp>
+      <p:sp>
+        <p:nvSpPr>
+          <p:cNvPr id="4" name="Rounded Rectangle 3"/>
+          <p:cNvSpPr/>
+          <p:nvPr/>
+        </p:nvSpPr>
+        <p:spPr>
+          <a:xfrm>
+            <a:off x="548640" y="1463040"/>
+            <a:ext cx="11064240" cy="548640"/>
+          </a:xfrm>
+          <a:prstGeom prst="roundRect">
+            <a:avLst>
+              <a:gd name="adj" fmla="val 12000"/>
+            </a:avLst>
+          </a:prstGeom>
+          <a:solidFill>
+            <a:srgbClr val="111311"/>
+          </a:solidFill>
+          <a:ln w="15875">
+            <a:solidFill>
+              <a:srgbClr val="111311"/>
+            </a:solidFill>
+          </a:ln>
+        </p:spPr>
+        <p:style>
+          <a:lnRef idx="1">
+            <a:schemeClr val="accent1"/>
+          </a:lnRef>
+          <a:fillRef idx="3">
+            <a:schemeClr val="accent1"/>
+          </a:fillRef>
+          <a:effectRef idx="2">
+            <a:schemeClr val="accent1"/>
+          </a:effectRef>
+          <a:fontRef idx="minor">
+            <a:schemeClr val="lt1"/>
+          </a:fontRef>
+        </p:style>
+        <p:txBody>
+          <a:bodyPr rtlCol="0" anchor="ctr"/>
+          <a:lstStyle/>
+          <a:p>
+            <a:pPr algn="ctr"/>
+          </a:p>
+        </p:txBody>
+      </p:sp>
+      <p:sp>
+        <p:nvSpPr>
+          <p:cNvPr id="5" name="TextBox 4"/>
+          <p:cNvSpPr txBox="1"/>
+          <p:nvPr/>
+        </p:nvSpPr>
+        <p:spPr>
+          <a:xfrm>
+            <a:off x="868680" y="1536192"/>
+            <a:ext cx="2926080" cy="411480"/>
+          </a:xfrm>
+          <a:prstGeom prst="rect">
+            <a:avLst/>
+          </a:prstGeom>
+          <a:noFill/>
+        </p:spPr>
+        <p:txBody>
+          <a:bodyPr wrap="square" lIns="0" rIns="0" anchor="t">
+            <a:noAutofit/>
+          </a:bodyPr>
+          <a:lstStyle/>
+          <a:p>
+            <a:pPr algn="ctr">
+              <a:lnSpc>
+                <a:spcPct val="115000"/>
+              </a:lnSpc>
+              <a:defRPr sz="1200" b="1">
+                <a:solidFill>
+                  <a:srgbClr val="FFFFFF"/>
+                </a:solidFill>
+              </a:defRPr>
+            </a:pPr>
+          </a:p>
+        </p:txBody>
+      </p:sp>
+      <p:sp>
+        <p:nvSpPr>
+          <p:cNvPr id="6" name="TextBox 5"/>
+          <p:cNvSpPr txBox="1"/>
+          <p:nvPr/>
+        </p:nvSpPr>
+        <p:spPr>
+          <a:xfrm>
+            <a:off x="4023360" y="1536192"/>
+            <a:ext cx="3383280" cy="411480"/>
+          </a:xfrm>
+          <a:prstGeom prst="rect">
+            <a:avLst/>
+          </a:prstGeom>
+          <a:noFill/>
+        </p:spPr>
+        <p:txBody>
+          <a:bodyPr wrap="square" lIns="0" rIns="0" anchor="t">
+            <a:noAutofit/>
+          </a:bodyPr>
+          <a:lstStyle/>
+          <a:p>
+            <a:pPr algn="ctr">
+              <a:lnSpc>
+                <a:spcPct val="115000"/>
+              </a:lnSpc>
+              <a:defRPr sz="1200" b="1">
+                <a:solidFill>
+                  <a:srgbClr val="FFFFFF"/>
+                </a:solidFill>
+              </a:defRPr>
+            </a:pPr>
+            <a:r>
+              <a:rPr>
+                <a:latin typeface="Meiryo"/>
+                <a:ea typeface="Meiryo"/>
+                <a:cs typeface="Meiryo"/>
+              </a:rPr>
+              <a:t>短期（選考期）</a:t>
+            </a:r>
+          </a:p>
+        </p:txBody>
+      </p:sp>
+      <p:sp>
+        <p:nvSpPr>
+          <p:cNvPr id="7" name="TextBox 6"/>
+          <p:cNvSpPr txBox="1"/>
+          <p:nvPr/>
+        </p:nvSpPr>
+        <p:spPr>
+          <a:xfrm>
+            <a:off x="7680960" y="1536192"/>
+            <a:ext cx="3383280" cy="411480"/>
+          </a:xfrm>
+          <a:prstGeom prst="rect">
+            <a:avLst/>
+          </a:prstGeom>
+          <a:noFill/>
+        </p:spPr>
+        <p:txBody>
+          <a:bodyPr wrap="square" lIns="0" rIns="0" anchor="t">
+            <a:noAutofit/>
+          </a:bodyPr>
+          <a:lstStyle/>
+          <a:p>
+            <a:pPr algn="ctr">
+              <a:lnSpc>
+                <a:spcPct val="115000"/>
+              </a:lnSpc>
+              <a:defRPr sz="1200" b="1">
+                <a:solidFill>
+                  <a:srgbClr val="FFFFFF"/>
+                </a:solidFill>
+              </a:defRPr>
+            </a:pPr>
+            <a:r>
+              <a:rPr>
+                <a:latin typeface="Meiryo"/>
+                <a:ea typeface="Meiryo"/>
+                <a:cs typeface="Meiryo"/>
+              </a:rPr>
+              <a:t>長期（入社後）</a:t>
+            </a:r>
+          </a:p>
+        </p:txBody>
+      </p:sp>
+      <p:sp>
+        <p:nvSpPr>
+          <p:cNvPr id="8" name="Rounded Rectangle 7"/>
+          <p:cNvSpPr/>
+          <p:nvPr/>
+        </p:nvSpPr>
+        <p:spPr>
+          <a:xfrm>
+            <a:off x="548640" y="2148840"/>
+            <a:ext cx="11064240" cy="960120"/>
+          </a:xfrm>
+          <a:prstGeom prst="roundRect">
+            <a:avLst>
+              <a:gd name="adj" fmla="val 12000"/>
+            </a:avLst>
+          </a:prstGeom>
+          <a:solidFill>
+            <a:srgbClr val="FFFFFF"/>
+          </a:solidFill>
+          <a:ln w="15875">
+            <a:solidFill>
+              <a:srgbClr val="E5E1D8"/>
+            </a:solidFill>
+          </a:ln>
+        </p:spPr>
+        <p:style>
+          <a:lnRef idx="1">
+            <a:schemeClr val="accent1"/>
+          </a:lnRef>
+          <a:fillRef idx="3">
+            <a:schemeClr val="accent1"/>
+          </a:fillRef>
+          <a:effectRef idx="2">
+            <a:schemeClr val="accent1"/>
+          </a:effectRef>
+          <a:fontRef idx="minor">
+            <a:schemeClr val="lt1"/>
+          </a:fontRef>
+        </p:style>
+        <p:txBody>
+          <a:bodyPr rtlCol="0" anchor="ctr"/>
+          <a:lstStyle/>
+          <a:p>
+            <a:pPr algn="ctr"/>
+          </a:p>
+        </p:txBody>
+      </p:sp>
+      <p:sp>
+        <p:nvSpPr>
+          <p:cNvPr id="9" name="TextBox 8"/>
+          <p:cNvSpPr txBox="1"/>
+          <p:nvPr/>
+        </p:nvSpPr>
+        <p:spPr>
+          <a:xfrm>
+            <a:off x="868680" y="2258568"/>
+            <a:ext cx="2926080" cy="731520"/>
+          </a:xfrm>
+          <a:prstGeom prst="rect">
+            <a:avLst/>
+          </a:prstGeom>
+          <a:noFill/>
+        </p:spPr>
+        <p:txBody>
+          <a:bodyPr wrap="square" lIns="0" rIns="0" anchor="t">
+            <a:noAutofit/>
+          </a:bodyPr>
+          <a:lstStyle/>
+          <a:p>
+            <a:pPr algn="ctr">
+              <a:lnSpc>
+                <a:spcPct val="115000"/>
+              </a:lnSpc>
+              <a:defRPr sz="1300" b="1">
+                <a:solidFill>
+                  <a:srgbClr val="111311"/>
+                </a:solidFill>
+              </a:defRPr>
+            </a:pPr>
+            <a:r>
+              <a:rPr>
+                <a:latin typeface="Meiryo"/>
+                <a:ea typeface="Meiryo"/>
+                <a:cs typeface="Meiryo"/>
+              </a:rPr>
+              <a:t>学生</a:t>
+            </a:r>
+          </a:p>
+        </p:txBody>
+      </p:sp>
+      <p:sp>
+        <p:nvSpPr>
+          <p:cNvPr id="10" name="TextBox 9"/>
+          <p:cNvSpPr txBox="1"/>
+          <p:nvPr/>
+        </p:nvSpPr>
+        <p:spPr>
+          <a:xfrm>
+            <a:off x="4023360" y="2258568"/>
+            <a:ext cx="3383280" cy="731520"/>
+          </a:xfrm>
+          <a:prstGeom prst="rect">
+            <a:avLst/>
+          </a:prstGeom>
+          <a:noFill/>
+        </p:spPr>
+        <p:txBody>
+          <a:bodyPr wrap="square" lIns="0" rIns="0" anchor="t">
+            <a:noAutofit/>
+          </a:bodyPr>
+          <a:lstStyle/>
+          <a:p>
+            <a:pPr algn="ctr">
+              <a:lnSpc>
+                <a:spcPct val="115000"/>
+              </a:lnSpc>
+              <a:defRPr sz="1100" b="0">
+                <a:solidFill>
+                  <a:srgbClr val="111311"/>
+                </a:solidFill>
+              </a:defRPr>
+            </a:pPr>
+            <a:r>
+              <a:rPr>
+                <a:latin typeface="Meiryo"/>
+                <a:ea typeface="Meiryo"/>
+                <a:cs typeface="Meiryo"/>
+              </a:rPr>
+              <a:t>自信なき応募・手戻り</a:t>
+            </a:r>
+          </a:p>
+        </p:txBody>
+      </p:sp>
+      <p:sp>
+        <p:nvSpPr>
+          <p:cNvPr id="11" name="TextBox 10"/>
+          <p:cNvSpPr txBox="1"/>
+          <p:nvPr/>
+        </p:nvSpPr>
+        <p:spPr>
+          <a:xfrm>
+            <a:off x="7680960" y="2258568"/>
+            <a:ext cx="3383280" cy="731520"/>
+          </a:xfrm>
+          <a:prstGeom prst="rect">
+            <a:avLst/>
+          </a:prstGeom>
+          <a:noFill/>
+        </p:spPr>
+        <p:txBody>
+          <a:bodyPr wrap="square" lIns="0" rIns="0" anchor="t">
+            <a:noAutofit/>
+          </a:bodyPr>
+          <a:lstStyle/>
+          <a:p>
+            <a:pPr algn="ctr">
+              <a:lnSpc>
+                <a:spcPct val="115000"/>
+              </a:lnSpc>
+              <a:defRPr sz="1100" b="0">
+                <a:solidFill>
+                  <a:srgbClr val="111311"/>
+                </a:solidFill>
+              </a:defRPr>
+            </a:pPr>
+            <a:r>
+              <a:rPr>
+                <a:latin typeface="Meiryo"/>
+                <a:ea typeface="Meiryo"/>
+                <a:cs typeface="Meiryo"/>
+              </a:rPr>
+              <a:t>納得低下・ミスマッチ</a:t>
+            </a:r>
+          </a:p>
+        </p:txBody>
+      </p:sp>
+      <p:sp>
+        <p:nvSpPr>
+          <p:cNvPr id="12" name="Rounded Rectangle 11"/>
+          <p:cNvSpPr/>
+          <p:nvPr/>
+        </p:nvSpPr>
+        <p:spPr>
+          <a:xfrm>
+            <a:off x="548640" y="3227832"/>
+            <a:ext cx="11064240" cy="960120"/>
+          </a:xfrm>
+          <a:prstGeom prst="roundRect">
+            <a:avLst>
+              <a:gd name="adj" fmla="val 12000"/>
+            </a:avLst>
+          </a:prstGeom>
+          <a:solidFill>
+            <a:srgbClr val="FFFFFF"/>
+          </a:solidFill>
+          <a:ln w="15875">
+            <a:solidFill>
+              <a:srgbClr val="E5E1D8"/>
+            </a:solidFill>
+          </a:ln>
+        </p:spPr>
+        <p:style>
+          <a:lnRef idx="1">
+            <a:schemeClr val="accent1"/>
+          </a:lnRef>
+          <a:fillRef idx="3">
+            <a:schemeClr val="accent1"/>
+          </a:fillRef>
+          <a:effectRef idx="2">
+            <a:schemeClr val="accent1"/>
+          </a:effectRef>
+          <a:fontRef idx="minor">
+            <a:schemeClr val="lt1"/>
+          </a:fontRef>
+        </p:style>
+        <p:txBody>
+          <a:bodyPr rtlCol="0" anchor="ctr"/>
+          <a:lstStyle/>
+          <a:p>
+            <a:pPr algn="ctr"/>
+          </a:p>
+        </p:txBody>
+      </p:sp>
+      <p:sp>
+        <p:nvSpPr>
+          <p:cNvPr id="13" name="TextBox 12"/>
+          <p:cNvSpPr txBox="1"/>
+          <p:nvPr/>
+        </p:nvSpPr>
+        <p:spPr>
+          <a:xfrm>
+            <a:off x="868680" y="3337560"/>
+            <a:ext cx="2926080" cy="731520"/>
+          </a:xfrm>
+          <a:prstGeom prst="rect">
+            <a:avLst/>
+          </a:prstGeom>
+          <a:noFill/>
+        </p:spPr>
+        <p:txBody>
+          <a:bodyPr wrap="square" lIns="0" rIns="0" anchor="t">
+            <a:noAutofit/>
+          </a:bodyPr>
+          <a:lstStyle/>
+          <a:p>
+            <a:pPr algn="ctr">
+              <a:lnSpc>
+                <a:spcPct val="115000"/>
+              </a:lnSpc>
+              <a:defRPr sz="1300" b="1">
+                <a:solidFill>
+                  <a:srgbClr val="111311"/>
+                </a:solidFill>
+              </a:defRPr>
+            </a:pPr>
+            <a:r>
+              <a:rPr>
+                <a:latin typeface="Meiryo"/>
+                <a:ea typeface="Meiryo"/>
+                <a:cs typeface="Meiryo"/>
+              </a:rPr>
+              <a:t>企業</a:t>
+            </a:r>
+          </a:p>
+        </p:txBody>
+      </p:sp>
+      <p:sp>
+        <p:nvSpPr>
+          <p:cNvPr id="14" name="TextBox 13"/>
+          <p:cNvSpPr txBox="1"/>
+          <p:nvPr/>
+        </p:nvSpPr>
+        <p:spPr>
+          <a:xfrm>
+            <a:off x="4023360" y="3337560"/>
+            <a:ext cx="3383280" cy="731520"/>
+          </a:xfrm>
+          <a:prstGeom prst="rect">
+            <a:avLst/>
+          </a:prstGeom>
+          <a:noFill/>
+        </p:spPr>
+        <p:txBody>
+          <a:bodyPr wrap="square" lIns="0" rIns="0" anchor="t">
+            <a:noAutofit/>
+          </a:bodyPr>
+          <a:lstStyle/>
+          <a:p>
+            <a:pPr algn="ctr">
+              <a:lnSpc>
+                <a:spcPct val="115000"/>
+              </a:lnSpc>
+              <a:defRPr sz="1100" b="0">
+                <a:solidFill>
+                  <a:srgbClr val="111311"/>
+                </a:solidFill>
+              </a:defRPr>
+            </a:pPr>
+            <a:r>
+              <a:rPr>
+                <a:latin typeface="Meiryo"/>
+                <a:ea typeface="Meiryo"/>
+                <a:cs typeface="Meiryo"/>
+              </a:rPr>
+              <a:t>人柄93.8%を評価不能</a:t>
+            </a:r>
+          </a:p>
+        </p:txBody>
+      </p:sp>
+      <p:sp>
+        <p:nvSpPr>
+          <p:cNvPr id="15" name="TextBox 14"/>
+          <p:cNvSpPr txBox="1"/>
+          <p:nvPr/>
+        </p:nvSpPr>
+        <p:spPr>
+          <a:xfrm>
+            <a:off x="7680960" y="3337560"/>
+            <a:ext cx="3383280" cy="731520"/>
+          </a:xfrm>
+          <a:prstGeom prst="rect">
+            <a:avLst/>
+          </a:prstGeom>
+          <a:noFill/>
+        </p:spPr>
+        <p:txBody>
+          <a:bodyPr wrap="square" lIns="0" rIns="0" anchor="t">
+            <a:noAutofit/>
+          </a:bodyPr>
+          <a:lstStyle/>
+          <a:p>
+            <a:pPr algn="ctr">
+              <a:lnSpc>
+                <a:spcPct val="115000"/>
+              </a:lnSpc>
+              <a:defRPr sz="1100" b="0">
+                <a:solidFill>
+                  <a:srgbClr val="111311"/>
+                </a:solidFill>
+              </a:defRPr>
+            </a:pPr>
+            <a:r>
+              <a:rPr>
+                <a:latin typeface="Meiryo"/>
+                <a:ea typeface="Meiryo"/>
+                <a:cs typeface="Meiryo"/>
+              </a:rPr>
+              <a:t>採用・定着コスト増</a:t>
+            </a:r>
+          </a:p>
+        </p:txBody>
+      </p:sp>
+      <p:sp>
+        <p:nvSpPr>
+          <p:cNvPr id="16" name="Rounded Rectangle 15"/>
+          <p:cNvSpPr/>
+          <p:nvPr/>
+        </p:nvSpPr>
+        <p:spPr>
+          <a:xfrm>
+            <a:off x="548640" y="4306824"/>
+            <a:ext cx="11064240" cy="960120"/>
+          </a:xfrm>
+          <a:prstGeom prst="roundRect">
+            <a:avLst>
+              <a:gd name="adj" fmla="val 12000"/>
+            </a:avLst>
+          </a:prstGeom>
+          <a:solidFill>
+            <a:srgbClr val="FFFFFF"/>
+          </a:solidFill>
+          <a:ln w="15875">
+            <a:solidFill>
+              <a:srgbClr val="E5E1D8"/>
+            </a:solidFill>
+          </a:ln>
+        </p:spPr>
+        <p:style>
+          <a:lnRef idx="1">
+            <a:schemeClr val="accent1"/>
+          </a:lnRef>
+          <a:fillRef idx="3">
+            <a:schemeClr val="accent1"/>
+          </a:fillRef>
+          <a:effectRef idx="2">
+            <a:schemeClr val="accent1"/>
+          </a:effectRef>
+          <a:fontRef idx="minor">
+            <a:schemeClr val="lt1"/>
+          </a:fontRef>
+        </p:style>
+        <p:txBody>
+          <a:bodyPr rtlCol="0" anchor="ctr"/>
+          <a:lstStyle/>
+          <a:p>
+            <a:pPr algn="ctr"/>
+          </a:p>
+        </p:txBody>
+      </p:sp>
+      <p:sp>
+        <p:nvSpPr>
+          <p:cNvPr id="17" name="TextBox 16"/>
+          <p:cNvSpPr txBox="1"/>
+          <p:nvPr/>
+        </p:nvSpPr>
+        <p:spPr>
+          <a:xfrm>
+            <a:off x="868680" y="4416552"/>
+            <a:ext cx="2926080" cy="731520"/>
+          </a:xfrm>
+          <a:prstGeom prst="rect">
+            <a:avLst/>
+          </a:prstGeom>
+          <a:noFill/>
+        </p:spPr>
+        <p:txBody>
+          <a:bodyPr wrap="square" lIns="0" rIns="0" anchor="t">
+            <a:noAutofit/>
+          </a:bodyPr>
+          <a:lstStyle/>
+          <a:p>
+            <a:pPr algn="ctr">
+              <a:lnSpc>
+                <a:spcPct val="115000"/>
+              </a:lnSpc>
+              <a:defRPr sz="1300" b="1">
+                <a:solidFill>
+                  <a:srgbClr val="111311"/>
+                </a:solidFill>
+              </a:defRPr>
+            </a:pPr>
+            <a:r>
+              <a:rPr>
+                <a:latin typeface="Meiryo"/>
+                <a:ea typeface="Meiryo"/>
+                <a:cs typeface="Meiryo"/>
+              </a:rPr>
+              <a:t>社会</a:t>
+            </a:r>
+          </a:p>
+        </p:txBody>
+      </p:sp>
+      <p:sp>
+        <p:nvSpPr>
+          <p:cNvPr id="18" name="TextBox 17"/>
+          <p:cNvSpPr txBox="1"/>
+          <p:nvPr/>
+        </p:nvSpPr>
+        <p:spPr>
+          <a:xfrm>
+            <a:off x="4023360" y="4416552"/>
+            <a:ext cx="3383280" cy="731520"/>
+          </a:xfrm>
+          <a:prstGeom prst="rect">
+            <a:avLst/>
+          </a:prstGeom>
+          <a:noFill/>
+        </p:spPr>
+        <p:txBody>
+          <a:bodyPr wrap="square" lIns="0" rIns="0" anchor="t">
+            <a:noAutofit/>
+          </a:bodyPr>
+          <a:lstStyle/>
+          <a:p>
+            <a:pPr algn="ctr">
+              <a:lnSpc>
+                <a:spcPct val="115000"/>
+              </a:lnSpc>
+              <a:defRPr sz="1100" b="0">
+                <a:solidFill>
+                  <a:srgbClr val="111311"/>
+                </a:solidFill>
+              </a:defRPr>
+            </a:pPr>
+            <a:r>
+              <a:rPr>
+                <a:latin typeface="Meiryo"/>
+                <a:ea typeface="Meiryo"/>
+                <a:cs typeface="Meiryo"/>
+              </a:rPr>
+              <a:t>支援の手戻り</a:t>
+            </a:r>
+          </a:p>
+        </p:txBody>
+      </p:sp>
+      <p:sp>
+        <p:nvSpPr>
+          <p:cNvPr id="19" name="TextBox 18"/>
+          <p:cNvSpPr txBox="1"/>
+          <p:nvPr/>
+        </p:nvSpPr>
+        <p:spPr>
+          <a:xfrm>
+            <a:off x="7680960" y="4416552"/>
+            <a:ext cx="3383280" cy="731520"/>
+          </a:xfrm>
+          <a:prstGeom prst="rect">
+            <a:avLst/>
+          </a:prstGeom>
+          <a:noFill/>
+        </p:spPr>
+        <p:txBody>
+          <a:bodyPr wrap="square" lIns="0" rIns="0" anchor="t">
+            <a:noAutofit/>
+          </a:bodyPr>
+          <a:lstStyle/>
+          <a:p>
+            <a:pPr algn="ctr">
+              <a:lnSpc>
+                <a:spcPct val="115000"/>
+              </a:lnSpc>
+              <a:defRPr sz="1100" b="0">
+                <a:solidFill>
+                  <a:srgbClr val="111311"/>
+                </a:solidFill>
+              </a:defRPr>
+            </a:pPr>
+            <a:r>
+              <a:rPr>
+                <a:latin typeface="Meiryo"/>
+                <a:ea typeface="Meiryo"/>
+                <a:cs typeface="Meiryo"/>
+              </a:rPr>
+              <a:t>早期離職・40%ギャップ</a:t>
+            </a:r>
+          </a:p>
+        </p:txBody>
+      </p:sp>
+      <p:sp>
+        <p:nvSpPr>
+          <p:cNvPr id="20" name="TextBox 19"/>
+          <p:cNvSpPr txBox="1"/>
+          <p:nvPr/>
+        </p:nvSpPr>
+        <p:spPr>
+          <a:xfrm>
+            <a:off x="548640" y="5486400"/>
+            <a:ext cx="11064240" cy="548640"/>
+          </a:xfrm>
+          <a:prstGeom prst="rect">
+            <a:avLst/>
+          </a:prstGeom>
+          <a:noFill/>
+        </p:spPr>
+        <p:txBody>
+          <a:bodyPr wrap="square" lIns="0" rIns="0" anchor="t">
+            <a:noAutofit/>
+          </a:bodyPr>
+          <a:lstStyle/>
+          <a:p>
+            <a:pPr algn="ctr">
+              <a:lnSpc>
+                <a:spcPct val="115000"/>
+              </a:lnSpc>
+              <a:defRPr sz="1100" b="0">
+                <a:solidFill>
+                  <a:srgbClr val="6B6F6B"/>
+                </a:solidFill>
+              </a:defRPr>
+            </a:pPr>
+            <a:r>
+              <a:rPr>
+                <a:latin typeface="Meiryo"/>
+                <a:ea typeface="Meiryo"/>
+                <a:cs typeface="Meiryo"/>
+              </a:rPr>
+              <a:t>だから解決に社会的価値がある ／ 出典：白書93.8%・社会人40%・学情60.7%</a:t>
+            </a:r>
+          </a:p>
+        </p:txBody>
+      </p:sp>
+    </p:spTree>
+  </p:cSld>
+  <p:clrMapOvr>
+    <a:masterClrMapping/>
+  </p:clrMapOvr>
+</p:sld>
+</file>
+
+<file path=ppt/slides/slide8.xml><?xml version="1.0" encoding="utf-8"?>
+<p:sld xmlns:a="http://schemas.openxmlformats.org/drawingml/2006/main" xmlns:p="http://schemas.openxmlformats.org/presentationml/2006/main" xmlns:r="http://schemas.openxmlformats.org/officeDocument/2006/relationships">
+  <p:cSld>
+    <p:bg>
+      <p:bgPr>
+        <a:solidFill>
+          <a:srgbClr val="F4F2EC"/>
+        </a:solidFill>
+        <a:effectLst/>
+      </p:bgPr>
+    </p:bg>
+    <p:spTree>
+      <p:nvGrpSpPr>
+        <p:cNvPr id="1" name=""/>
+        <p:cNvGrpSpPr/>
+        <p:nvPr/>
+      </p:nvGrpSpPr>
+      <p:grpSpPr/>
+      <p:sp>
+        <p:nvSpPr>
+          <p:cNvPr id="2" name="TextBox 1"/>
+          <p:cNvSpPr txBox="1"/>
+          <p:nvPr/>
+        </p:nvSpPr>
+        <p:spPr>
+          <a:xfrm>
+            <a:off x="548640" y="228600"/>
+            <a:ext cx="11064240" cy="365760"/>
+          </a:xfrm>
+          <a:prstGeom prst="rect">
+            <a:avLst/>
+          </a:prstGeom>
+          <a:noFill/>
+        </p:spPr>
+        <p:txBody>
+          <a:bodyPr wrap="square" lIns="0" rIns="0" anchor="t">
+            <a:noAutofit/>
+          </a:bodyPr>
+          <a:lstStyle/>
+          <a:p>
+            <a:pPr algn="l">
+              <a:lnSpc>
+                <a:spcPct val="115000"/>
+              </a:lnSpc>
+              <a:defRPr sz="1200" b="0">
+                <a:solidFill>
+                  <a:srgbClr val="6B6F6B"/>
+                </a:solidFill>
+              </a:defRPr>
+            </a:pPr>
+            <a:r>
+              <a:rPr>
+                <a:latin typeface="Meiryo"/>
+                <a:ea typeface="Meiryo"/>
+                <a:cs typeface="Meiryo"/>
+              </a:rPr>
+              <a:t>(07) まとめ &amp; 次へ</a:t>
             </a:r>
           </a:p>
         </p:txBody>

</xml_diff>